<commit_message>
docs: add Phase 04 (Gateway-routed tools & AgentCore Memory) to the report and deck
Word report: new Section 15 (objective, what each capability does, key
engineering decisions, issues found and fixed, live verification results,
business value), plus consistency updates everywhere the report previously
described Gateway/Memory as unbuilt placeholders (cover table, roadmap,
architecture table, advantages, glossary, conclusion).

Slide deck (renamed to include Phase 04): a new dedicated Phase 04 slide,
the title slide's phase badges, the cloud-architecture slide's Gateway/
Memory boxes, and the four-phase delivery-journey slide (previously only
showed three phases). The Current Status slide's Gateway/Memory row now
sits right after Phase 03 with a green "live-verified" pill instead of
grey "not yet wired in", and Staging/Production rollout moved to last.

Co-Authored-By: Claude Sonnet 5 <noreply@anthropic.com>
</commit_message>
<xml_diff>
--- a/docs/AMC_RFP_Orchestrator_Project_Phase01_Phase02_Phase03_Phase04.pptx
+++ b/docs/AMC_RFP_Orchestrator_Project_Phase01_Phase02_Phase03_Phase04.pptx
@@ -17,6 +17,7 @@
     <p:sldId id="271" r:id="rId22"/>
     <p:sldId id="264" r:id="rId15"/>
     <p:sldId id="265" r:id="rId16"/>
+    <p:sldId id="273" r:id="rId24"/>
     <p:sldId id="266" r:id="rId17"/>
     <p:sldId id="267" r:id="rId18"/>
     <p:sldId id="268" r:id="rId19"/>
@@ -3422,7 +3423,7 @@
                 </a:solidFill>
                 <a:latin typeface="Calibri"/>
               </a:rPr>
-              <a:t>Consolidated Project Report Deck (Phases 01–03)  •  July 2026</a:t>
+              <a:t>Consolidated Project Report Deck (Phases 01–04)  •  July 2026</a:t>
             </a:r>
           </a:p>
         </p:txBody>
@@ -3676,7 +3677,7 @@
                 </a:solidFill>
                 <a:latin typeface="Calibri"/>
               </a:rPr>
-              <a:t>Phase 01 — Local Development (Complete)      |      Phase 02 — AWS Cloud Deployment (Dev Proven)      |      Phase 03 — CI/CD Automation (Dev Proven)</a:t>
+              <a:t>Phase 01 — Local Development (Complete)      |      Phase 02 — AWS Cloud Deployment (Dev Proven)      |      Phase 03 — CI/CD Automation (Dev Proven)      |      Phase 04 — Gateway &amp; Memory (Dev Live-Verified)</a:t>
             </a:r>
           </a:p>
         </p:txBody>
@@ -5120,7 +5121,7 @@
                 </a:solidFill>
                 <a:latin typeface="Calibri"/>
               </a:rPr>
-              <a:t>10 / 17</a:t>
+              <a:t>10 / 18</a:t>
             </a:r>
           </a:p>
         </p:txBody>
@@ -6584,7 +6585,7 @@
                 </a:solidFill>
                 <a:latin typeface="Calibri"/>
               </a:rPr>
-              <a:t>(provisioned, not yet wired in)</a:t>
+              <a:t>(real tool logic, live-verified — Phase 04)</a:t>
             </a:r>
           </a:p>
         </p:txBody>
@@ -6662,7 +6663,7 @@
                 </a:solidFill>
                 <a:latin typeface="Calibri"/>
               </a:rPr>
-              <a:t>(provisioned, not yet wired in)</a:t>
+              <a:t>(real cross-turn read/write, live-verified — Phase 04)</a:t>
             </a:r>
           </a:p>
         </p:txBody>
@@ -6838,7 +6839,7 @@
                 </a:solidFill>
                 <a:latin typeface="Calibri"/>
               </a:rPr>
-              <a:t>11 / 17</a:t>
+              <a:t>11 / 18</a:t>
             </a:r>
           </a:p>
         </p:txBody>
@@ -8163,7 +8164,7 @@
                 </a:solidFill>
                 <a:latin typeface="Calibri"/>
               </a:rPr>
-              <a:t>12 / 17</a:t>
+              <a:t>12 / 18</a:t>
             </a:r>
           </a:p>
         </p:txBody>
@@ -8177,6 +8178,1366 @@
 </file>
 
 <file path=ppt/slides/slide13.xml><?xml version="1.0" encoding="utf-8"?>
+<p:sld xmlns:a="http://schemas.openxmlformats.org/drawingml/2006/main" xmlns:p="http://schemas.openxmlformats.org/presentationml/2006/main" xmlns:r="http://schemas.openxmlformats.org/officeDocument/2006/relationships">
+  <p:cSld>
+    <p:spTree>
+      <p:nvGrpSpPr>
+        <p:cNvPr id="1" name=""/>
+        <p:cNvGrpSpPr/>
+        <p:nvPr/>
+      </p:nvGrpSpPr>
+      <p:grpSpPr/>
+      <p:sp>
+        <p:nvSpPr>
+          <p:cNvPr id="2" name="Rectangle 1"/>
+          <p:cNvSpPr/>
+          <p:nvPr/>
+        </p:nvSpPr>
+        <p:spPr>
+          <a:xfrm>
+            <a:off x="0" y="0"/>
+            <a:ext cx="12191695" cy="960120"/>
+          </a:xfrm>
+          <a:prstGeom prst="rect">
+            <a:avLst/>
+          </a:prstGeom>
+          <a:solidFill>
+            <a:srgbClr val="232F3E"/>
+          </a:solidFill>
+          <a:ln>
+            <a:noFill/>
+          </a:ln>
+          <a:effectLst/>
+        </p:spPr>
+        <p:style>
+          <a:lnRef idx="1">
+            <a:schemeClr val="accent1"/>
+          </a:lnRef>
+          <a:fillRef idx="3">
+            <a:schemeClr val="accent1"/>
+          </a:fillRef>
+          <a:effectRef idx="2">
+            <a:schemeClr val="accent1"/>
+          </a:effectRef>
+          <a:fontRef idx="minor">
+            <a:schemeClr val="lt1"/>
+          </a:fontRef>
+        </p:style>
+        <p:txBody>
+          <a:bodyPr rtlCol="0" anchor="ctr"/>
+          <a:lstStyle/>
+          <a:p>
+            <a:pPr algn="ctr"/>
+          </a:p>
+        </p:txBody>
+      </p:sp>
+      <p:sp>
+        <p:nvSpPr>
+          <p:cNvPr id="3" name="Rectangle 2"/>
+          <p:cNvSpPr/>
+          <p:nvPr/>
+        </p:nvSpPr>
+        <p:spPr>
+          <a:xfrm>
+            <a:off x="0" y="960120"/>
+            <a:ext cx="12191695" cy="38100"/>
+          </a:xfrm>
+          <a:prstGeom prst="rect">
+            <a:avLst/>
+          </a:prstGeom>
+          <a:solidFill>
+            <a:srgbClr val="FF9900"/>
+          </a:solidFill>
+          <a:ln>
+            <a:noFill/>
+          </a:ln>
+          <a:effectLst/>
+        </p:spPr>
+        <p:style>
+          <a:lnRef idx="1">
+            <a:schemeClr val="accent1"/>
+          </a:lnRef>
+          <a:fillRef idx="3">
+            <a:schemeClr val="accent1"/>
+          </a:fillRef>
+          <a:effectRef idx="2">
+            <a:schemeClr val="accent1"/>
+          </a:effectRef>
+          <a:fontRef idx="minor">
+            <a:schemeClr val="lt1"/>
+          </a:fontRef>
+        </p:style>
+        <p:txBody>
+          <a:bodyPr rtlCol="0" anchor="ctr"/>
+          <a:lstStyle/>
+          <a:p>
+            <a:pPr algn="ctr"/>
+          </a:p>
+        </p:txBody>
+      </p:sp>
+      <p:sp>
+        <p:nvSpPr>
+          <p:cNvPr id="4" name="TextBox 3"/>
+          <p:cNvSpPr txBox="1"/>
+          <p:nvPr/>
+        </p:nvSpPr>
+        <p:spPr>
+          <a:xfrm>
+            <a:off x="457200" y="109728"/>
+            <a:ext cx="10058400" cy="292608"/>
+          </a:xfrm>
+          <a:prstGeom prst="rect">
+            <a:avLst/>
+          </a:prstGeom>
+          <a:noFill/>
+        </p:spPr>
+        <p:txBody>
+          <a:bodyPr wrap="square" anchor="t" lIns="0" rIns="0" tIns="0" bIns="0">
+            <a:spAutoFit/>
+          </a:bodyPr>
+          <a:lstStyle/>
+          <a:p>
+            <a:pPr algn="l">
+              <a:lnSpc>
+                <a:spcPct val="100000"/>
+              </a:lnSpc>
+            </a:pPr>
+            <a:r>
+              <a:rPr sz="1200" b="1" i="0">
+                <a:solidFill>
+                  <a:srgbClr val="FF9900"/>
+                </a:solidFill>
+                <a:latin typeface="Calibri"/>
+              </a:rPr>
+              <a:t>SECTION 17 · PHASE 04</a:t>
+            </a:r>
+          </a:p>
+        </p:txBody>
+      </p:sp>
+      <p:sp>
+        <p:nvSpPr>
+          <p:cNvPr id="5" name="TextBox 4"/>
+          <p:cNvSpPr txBox="1"/>
+          <p:nvPr/>
+        </p:nvSpPr>
+        <p:spPr>
+          <a:xfrm>
+            <a:off x="457200" y="384048"/>
+            <a:ext cx="10332720" cy="548640"/>
+          </a:xfrm>
+          <a:prstGeom prst="rect">
+            <a:avLst/>
+          </a:prstGeom>
+          <a:noFill/>
+        </p:spPr>
+        <p:txBody>
+          <a:bodyPr wrap="square" anchor="t" lIns="0" rIns="0" tIns="0" bIns="0">
+            <a:spAutoFit/>
+          </a:bodyPr>
+          <a:lstStyle/>
+          <a:p>
+            <a:pPr algn="l">
+              <a:lnSpc>
+                <a:spcPct val="100000"/>
+              </a:lnSpc>
+            </a:pPr>
+            <a:r>
+              <a:rPr sz="2500" b="1" i="0">
+                <a:solidFill>
+                  <a:srgbClr val="FFFFFF"/>
+                </a:solidFill>
+                <a:latin typeface="Calibri"/>
+              </a:rPr>
+              <a:t>Gateway-Routed Tools &amp; AgentCore Memory</a:t>
+            </a:r>
+          </a:p>
+        </p:txBody>
+      </p:sp>
+      <p:sp>
+        <p:nvSpPr>
+          <p:cNvPr id="6" name="TextBox 5"/>
+          <p:cNvSpPr txBox="1"/>
+          <p:nvPr/>
+        </p:nvSpPr>
+        <p:spPr>
+          <a:xfrm>
+            <a:off x="11247120" y="347472"/>
+            <a:ext cx="731520" cy="457200"/>
+          </a:xfrm>
+          <a:prstGeom prst="rect">
+            <a:avLst/>
+          </a:prstGeom>
+          <a:noFill/>
+        </p:spPr>
+        <p:txBody>
+          <a:bodyPr wrap="square" anchor="t" lIns="0" rIns="0" tIns="0" bIns="0">
+            <a:spAutoFit/>
+          </a:bodyPr>
+          <a:lstStyle/>
+          <a:p>
+            <a:pPr algn="r">
+              <a:lnSpc>
+                <a:spcPct val="100000"/>
+              </a:lnSpc>
+            </a:pPr>
+            <a:r>
+              <a:rPr sz="2000" b="1" i="0">
+                <a:solidFill>
+                  <a:srgbClr val="FF9900"/>
+                </a:solidFill>
+                <a:latin typeface="Calibri"/>
+              </a:rPr>
+              <a:t>13</a:t>
+            </a:r>
+          </a:p>
+        </p:txBody>
+      </p:sp>
+      <p:sp>
+        <p:nvSpPr>
+          <p:cNvPr id="7" name="TextBox 6"/>
+          <p:cNvSpPr txBox="1"/>
+          <p:nvPr/>
+        </p:nvSpPr>
+        <p:spPr>
+          <a:xfrm>
+            <a:off x="457200" y="1188720"/>
+            <a:ext cx="11247120" cy="548640"/>
+          </a:xfrm>
+          <a:prstGeom prst="rect">
+            <a:avLst/>
+          </a:prstGeom>
+          <a:noFill/>
+        </p:spPr>
+        <p:txBody>
+          <a:bodyPr wrap="square" anchor="t" lIns="0" rIns="0" tIns="0" bIns="0">
+            <a:spAutoFit/>
+          </a:bodyPr>
+          <a:lstStyle/>
+          <a:p>
+            <a:pPr algn="l">
+              <a:lnSpc>
+                <a:spcPct val="115000"/>
+              </a:lnSpc>
+            </a:pPr>
+            <a:r>
+              <a:rPr sz="1350" b="0" i="0">
+                <a:solidFill>
+                  <a:srgbClr val="5A636E"/>
+                </a:solidFill>
+                <a:latin typeface="Calibri"/>
+              </a:rPr>
+              <a:t>Two AWS capabilities provisioned since Phase 02 — governed tool access and cross-turn conversation memory — are now real, working, and live-verified end-to-end against real AWS.</a:t>
+            </a:r>
+          </a:p>
+        </p:txBody>
+      </p:sp>
+      <p:sp>
+        <p:nvSpPr>
+          <p:cNvPr id="8" name="Rounded Rectangle 7"/>
+          <p:cNvSpPr/>
+          <p:nvPr/>
+        </p:nvSpPr>
+        <p:spPr>
+          <a:xfrm>
+            <a:off x="457200" y="1920240"/>
+            <a:ext cx="3639312" cy="2148840"/>
+          </a:xfrm>
+          <a:prstGeom prst="roundRect">
+            <a:avLst>
+              <a:gd name="adj" fmla="val 5000"/>
+            </a:avLst>
+          </a:prstGeom>
+          <a:solidFill>
+            <a:srgbClr val="FFFFFF"/>
+          </a:solidFill>
+          <a:ln w="12700">
+            <a:solidFill>
+              <a:srgbClr val="DDE1E6"/>
+            </a:solidFill>
+          </a:ln>
+          <a:effectLst/>
+        </p:spPr>
+        <p:style>
+          <a:lnRef idx="1">
+            <a:schemeClr val="accent1"/>
+          </a:lnRef>
+          <a:fillRef idx="3">
+            <a:schemeClr val="accent1"/>
+          </a:fillRef>
+          <a:effectRef idx="2">
+            <a:schemeClr val="accent1"/>
+          </a:effectRef>
+          <a:fontRef idx="minor">
+            <a:schemeClr val="lt1"/>
+          </a:fontRef>
+        </p:style>
+        <p:txBody>
+          <a:bodyPr rtlCol="0" anchor="ctr"/>
+          <a:lstStyle/>
+          <a:p>
+            <a:pPr algn="ctr"/>
+          </a:p>
+        </p:txBody>
+      </p:sp>
+      <p:sp>
+        <p:nvSpPr>
+          <p:cNvPr id="9" name="Rectangle 8"/>
+          <p:cNvSpPr/>
+          <p:nvPr/>
+        </p:nvSpPr>
+        <p:spPr>
+          <a:xfrm>
+            <a:off x="457200" y="1920240"/>
+            <a:ext cx="73152" cy="2148840"/>
+          </a:xfrm>
+          <a:prstGeom prst="rect">
+            <a:avLst/>
+          </a:prstGeom>
+          <a:solidFill>
+            <a:srgbClr val="146EB4"/>
+          </a:solidFill>
+          <a:ln>
+            <a:noFill/>
+          </a:ln>
+          <a:effectLst/>
+        </p:spPr>
+        <p:style>
+          <a:lnRef idx="1">
+            <a:schemeClr val="accent1"/>
+          </a:lnRef>
+          <a:fillRef idx="3">
+            <a:schemeClr val="accent1"/>
+          </a:fillRef>
+          <a:effectRef idx="2">
+            <a:schemeClr val="accent1"/>
+          </a:effectRef>
+          <a:fontRef idx="minor">
+            <a:schemeClr val="lt1"/>
+          </a:fontRef>
+        </p:style>
+        <p:txBody>
+          <a:bodyPr rtlCol="0" anchor="ctr"/>
+          <a:lstStyle/>
+          <a:p>
+            <a:pPr algn="ctr"/>
+          </a:p>
+        </p:txBody>
+      </p:sp>
+      <p:sp>
+        <p:nvSpPr>
+          <p:cNvPr id="10" name="TextBox 9"/>
+          <p:cNvSpPr txBox="1"/>
+          <p:nvPr/>
+        </p:nvSpPr>
+        <p:spPr>
+          <a:xfrm>
+            <a:off x="685800" y="2066544"/>
+            <a:ext cx="3227832" cy="457200"/>
+          </a:xfrm>
+          <a:prstGeom prst="rect">
+            <a:avLst/>
+          </a:prstGeom>
+          <a:noFill/>
+        </p:spPr>
+        <p:txBody>
+          <a:bodyPr wrap="square" anchor="t" lIns="0" rIns="0" tIns="0" bIns="0">
+            <a:spAutoFit/>
+          </a:bodyPr>
+          <a:lstStyle/>
+          <a:p>
+            <a:pPr algn="l">
+              <a:lnSpc>
+                <a:spcPct val="100000"/>
+              </a:lnSpc>
+            </a:pPr>
+            <a:r>
+              <a:rPr sz="1350" b="1" i="0">
+                <a:solidFill>
+                  <a:srgbClr val="232F3E"/>
+                </a:solidFill>
+                <a:latin typeface="Calibri"/>
+              </a:rPr>
+              <a:t>AgentCore Gateway</a:t>
+            </a:r>
+          </a:p>
+        </p:txBody>
+      </p:sp>
+      <p:sp>
+        <p:nvSpPr>
+          <p:cNvPr id="11" name="TextBox 10"/>
+          <p:cNvSpPr txBox="1"/>
+          <p:nvPr/>
+        </p:nvSpPr>
+        <p:spPr>
+          <a:xfrm>
+            <a:off x="685800" y="2542032"/>
+            <a:ext cx="3227832" cy="1371600"/>
+          </a:xfrm>
+          <a:prstGeom prst="rect">
+            <a:avLst/>
+          </a:prstGeom>
+          <a:noFill/>
+        </p:spPr>
+        <p:txBody>
+          <a:bodyPr wrap="square" anchor="t" lIns="0" rIns="0" tIns="0" bIns="0">
+            <a:spAutoFit/>
+          </a:bodyPr>
+          <a:lstStyle/>
+          <a:p>
+            <a:pPr algn="l">
+              <a:lnSpc>
+                <a:spcPct val="115000"/>
+              </a:lnSpc>
+            </a:pPr>
+            <a:r>
+              <a:rPr sz="1050" b="0" i="0">
+                <a:solidFill>
+                  <a:srgbClr val="5A636E"/>
+                </a:solidFill>
+                <a:latin typeface="Calibri"/>
+              </a:rPr>
+              <a:t>Data-retrieval tools now route through AWS's governed Gateway — one authenticated access point, reusable by other systems or future agents, not just this app.</a:t>
+            </a:r>
+          </a:p>
+        </p:txBody>
+      </p:sp>
+      <p:sp>
+        <p:nvSpPr>
+          <p:cNvPr id="12" name="Rounded Rectangle 11"/>
+          <p:cNvSpPr/>
+          <p:nvPr/>
+        </p:nvSpPr>
+        <p:spPr>
+          <a:xfrm>
+            <a:off x="4233672" y="1920240"/>
+            <a:ext cx="3639312" cy="2148840"/>
+          </a:xfrm>
+          <a:prstGeom prst="roundRect">
+            <a:avLst>
+              <a:gd name="adj" fmla="val 5000"/>
+            </a:avLst>
+          </a:prstGeom>
+          <a:solidFill>
+            <a:srgbClr val="FFFFFF"/>
+          </a:solidFill>
+          <a:ln w="12700">
+            <a:solidFill>
+              <a:srgbClr val="DDE1E6"/>
+            </a:solidFill>
+          </a:ln>
+          <a:effectLst/>
+        </p:spPr>
+        <p:style>
+          <a:lnRef idx="1">
+            <a:schemeClr val="accent1"/>
+          </a:lnRef>
+          <a:fillRef idx="3">
+            <a:schemeClr val="accent1"/>
+          </a:fillRef>
+          <a:effectRef idx="2">
+            <a:schemeClr val="accent1"/>
+          </a:effectRef>
+          <a:fontRef idx="minor">
+            <a:schemeClr val="lt1"/>
+          </a:fontRef>
+        </p:style>
+        <p:txBody>
+          <a:bodyPr rtlCol="0" anchor="ctr"/>
+          <a:lstStyle/>
+          <a:p>
+            <a:pPr algn="ctr"/>
+          </a:p>
+        </p:txBody>
+      </p:sp>
+      <p:sp>
+        <p:nvSpPr>
+          <p:cNvPr id="13" name="Rectangle 12"/>
+          <p:cNvSpPr/>
+          <p:nvPr/>
+        </p:nvSpPr>
+        <p:spPr>
+          <a:xfrm>
+            <a:off x="4233672" y="1920240"/>
+            <a:ext cx="73152" cy="2148840"/>
+          </a:xfrm>
+          <a:prstGeom prst="rect">
+            <a:avLst/>
+          </a:prstGeom>
+          <a:solidFill>
+            <a:srgbClr val="146EB4"/>
+          </a:solidFill>
+          <a:ln>
+            <a:noFill/>
+          </a:ln>
+          <a:effectLst/>
+        </p:spPr>
+        <p:style>
+          <a:lnRef idx="1">
+            <a:schemeClr val="accent1"/>
+          </a:lnRef>
+          <a:fillRef idx="3">
+            <a:schemeClr val="accent1"/>
+          </a:fillRef>
+          <a:effectRef idx="2">
+            <a:schemeClr val="accent1"/>
+          </a:effectRef>
+          <a:fontRef idx="minor">
+            <a:schemeClr val="lt1"/>
+          </a:fontRef>
+        </p:style>
+        <p:txBody>
+          <a:bodyPr rtlCol="0" anchor="ctr"/>
+          <a:lstStyle/>
+          <a:p>
+            <a:pPr algn="ctr"/>
+          </a:p>
+        </p:txBody>
+      </p:sp>
+      <p:sp>
+        <p:nvSpPr>
+          <p:cNvPr id="14" name="TextBox 13"/>
+          <p:cNvSpPr txBox="1"/>
+          <p:nvPr/>
+        </p:nvSpPr>
+        <p:spPr>
+          <a:xfrm>
+            <a:off x="4462272" y="2066544"/>
+            <a:ext cx="3227832" cy="457200"/>
+          </a:xfrm>
+          <a:prstGeom prst="rect">
+            <a:avLst/>
+          </a:prstGeom>
+          <a:noFill/>
+        </p:spPr>
+        <p:txBody>
+          <a:bodyPr wrap="square" anchor="t" lIns="0" rIns="0" tIns="0" bIns="0">
+            <a:spAutoFit/>
+          </a:bodyPr>
+          <a:lstStyle/>
+          <a:p>
+            <a:pPr algn="l">
+              <a:lnSpc>
+                <a:spcPct val="100000"/>
+              </a:lnSpc>
+            </a:pPr>
+            <a:r>
+              <a:rPr sz="1350" b="1" i="0">
+                <a:solidFill>
+                  <a:srgbClr val="232F3E"/>
+                </a:solidFill>
+                <a:latin typeface="Calibri"/>
+              </a:rPr>
+              <a:t>AgentCore Memory</a:t>
+            </a:r>
+          </a:p>
+        </p:txBody>
+      </p:sp>
+      <p:sp>
+        <p:nvSpPr>
+          <p:cNvPr id="15" name="TextBox 14"/>
+          <p:cNvSpPr txBox="1"/>
+          <p:nvPr/>
+        </p:nvSpPr>
+        <p:spPr>
+          <a:xfrm>
+            <a:off x="4462272" y="2542032"/>
+            <a:ext cx="3227832" cy="1371600"/>
+          </a:xfrm>
+          <a:prstGeom prst="rect">
+            <a:avLst/>
+          </a:prstGeom>
+          <a:noFill/>
+        </p:spPr>
+        <p:txBody>
+          <a:bodyPr wrap="square" anchor="t" lIns="0" rIns="0" tIns="0" bIns="0">
+            <a:spAutoFit/>
+          </a:bodyPr>
+          <a:lstStyle/>
+          <a:p>
+            <a:pPr algn="l">
+              <a:lnSpc>
+                <a:spcPct val="115000"/>
+              </a:lnSpc>
+            </a:pPr>
+            <a:r>
+              <a:rPr sz="1050" b="0" i="0">
+                <a:solidFill>
+                  <a:srgbClr val="5A636E"/>
+                </a:solidFill>
+                <a:latin typeface="Calibri"/>
+              </a:rPr>
+              <a:t>The system now retains a client’s earlier questions within a conversation, correctly resolving a follow-up like “that fund” back to what was asked before — without weakening compliance.</a:t>
+            </a:r>
+          </a:p>
+        </p:txBody>
+      </p:sp>
+      <p:sp>
+        <p:nvSpPr>
+          <p:cNvPr id="16" name="Rounded Rectangle 15"/>
+          <p:cNvSpPr/>
+          <p:nvPr/>
+        </p:nvSpPr>
+        <p:spPr>
+          <a:xfrm>
+            <a:off x="8010144" y="1920240"/>
+            <a:ext cx="3639312" cy="2148840"/>
+          </a:xfrm>
+          <a:prstGeom prst="roundRect">
+            <a:avLst>
+              <a:gd name="adj" fmla="val 5000"/>
+            </a:avLst>
+          </a:prstGeom>
+          <a:solidFill>
+            <a:srgbClr val="FFFFFF"/>
+          </a:solidFill>
+          <a:ln w="12700">
+            <a:solidFill>
+              <a:srgbClr val="DDE1E6"/>
+            </a:solidFill>
+          </a:ln>
+          <a:effectLst/>
+        </p:spPr>
+        <p:style>
+          <a:lnRef idx="1">
+            <a:schemeClr val="accent1"/>
+          </a:lnRef>
+          <a:fillRef idx="3">
+            <a:schemeClr val="accent1"/>
+          </a:fillRef>
+          <a:effectRef idx="2">
+            <a:schemeClr val="accent1"/>
+          </a:effectRef>
+          <a:fontRef idx="minor">
+            <a:schemeClr val="lt1"/>
+          </a:fontRef>
+        </p:style>
+        <p:txBody>
+          <a:bodyPr rtlCol="0" anchor="ctr"/>
+          <a:lstStyle/>
+          <a:p>
+            <a:pPr algn="ctr"/>
+          </a:p>
+        </p:txBody>
+      </p:sp>
+      <p:sp>
+        <p:nvSpPr>
+          <p:cNvPr id="17" name="Rectangle 16"/>
+          <p:cNvSpPr/>
+          <p:nvPr/>
+        </p:nvSpPr>
+        <p:spPr>
+          <a:xfrm>
+            <a:off x="8010144" y="1920240"/>
+            <a:ext cx="73152" cy="2148840"/>
+          </a:xfrm>
+          <a:prstGeom prst="rect">
+            <a:avLst/>
+          </a:prstGeom>
+          <a:solidFill>
+            <a:srgbClr val="146EB4"/>
+          </a:solidFill>
+          <a:ln>
+            <a:noFill/>
+          </a:ln>
+          <a:effectLst/>
+        </p:spPr>
+        <p:style>
+          <a:lnRef idx="1">
+            <a:schemeClr val="accent1"/>
+          </a:lnRef>
+          <a:fillRef idx="3">
+            <a:schemeClr val="accent1"/>
+          </a:fillRef>
+          <a:effectRef idx="2">
+            <a:schemeClr val="accent1"/>
+          </a:effectRef>
+          <a:fontRef idx="minor">
+            <a:schemeClr val="lt1"/>
+          </a:fontRef>
+        </p:style>
+        <p:txBody>
+          <a:bodyPr rtlCol="0" anchor="ctr"/>
+          <a:lstStyle/>
+          <a:p>
+            <a:pPr algn="ctr"/>
+          </a:p>
+        </p:txBody>
+      </p:sp>
+      <p:sp>
+        <p:nvSpPr>
+          <p:cNvPr id="18" name="TextBox 17"/>
+          <p:cNvSpPr txBox="1"/>
+          <p:nvPr/>
+        </p:nvSpPr>
+        <p:spPr>
+          <a:xfrm>
+            <a:off x="8238744" y="2066544"/>
+            <a:ext cx="3227832" cy="457200"/>
+          </a:xfrm>
+          <a:prstGeom prst="rect">
+            <a:avLst/>
+          </a:prstGeom>
+          <a:noFill/>
+        </p:spPr>
+        <p:txBody>
+          <a:bodyPr wrap="square" anchor="t" lIns="0" rIns="0" tIns="0" bIns="0">
+            <a:spAutoFit/>
+          </a:bodyPr>
+          <a:lstStyle/>
+          <a:p>
+            <a:pPr algn="l">
+              <a:lnSpc>
+                <a:spcPct val="100000"/>
+              </a:lnSpc>
+            </a:pPr>
+            <a:r>
+              <a:rPr sz="1350" b="1" i="0">
+                <a:solidFill>
+                  <a:srgbClr val="232F3E"/>
+                </a:solidFill>
+                <a:latin typeface="Calibri"/>
+              </a:rPr>
+              <a:t>Opt-In, Zero Behaviour Change</a:t>
+            </a:r>
+          </a:p>
+        </p:txBody>
+      </p:sp>
+      <p:sp>
+        <p:nvSpPr>
+          <p:cNvPr id="19" name="TextBox 18"/>
+          <p:cNvSpPr txBox="1"/>
+          <p:nvPr/>
+        </p:nvSpPr>
+        <p:spPr>
+          <a:xfrm>
+            <a:off x="8238744" y="2542032"/>
+            <a:ext cx="3227832" cy="1371600"/>
+          </a:xfrm>
+          <a:prstGeom prst="rect">
+            <a:avLst/>
+          </a:prstGeom>
+          <a:noFill/>
+        </p:spPr>
+        <p:txBody>
+          <a:bodyPr wrap="square" anchor="t" lIns="0" rIns="0" tIns="0" bIns="0">
+            <a:spAutoFit/>
+          </a:bodyPr>
+          <a:lstStyle/>
+          <a:p>
+            <a:pPr algn="l">
+              <a:lnSpc>
+                <a:spcPct val="115000"/>
+              </a:lnSpc>
+            </a:pPr>
+            <a:r>
+              <a:rPr sz="1050" b="0" i="0">
+                <a:solidFill>
+                  <a:srgbClr val="5A636E"/>
+                </a:solidFill>
+                <a:latin typeface="Calibri"/>
+              </a:rPr>
+              <a:t>Both capabilities are additive and independently switchable by configuration — existing direct-access, single-turn behaviour remains fully available when neither is switched on.</a:t>
+            </a:r>
+          </a:p>
+        </p:txBody>
+      </p:sp>
+      <p:sp>
+        <p:nvSpPr>
+          <p:cNvPr id="20" name="Rounded Rectangle 19"/>
+          <p:cNvSpPr/>
+          <p:nvPr/>
+        </p:nvSpPr>
+        <p:spPr>
+          <a:xfrm>
+            <a:off x="457200" y="4233672"/>
+            <a:ext cx="3639312" cy="2148840"/>
+          </a:xfrm>
+          <a:prstGeom prst="roundRect">
+            <a:avLst>
+              <a:gd name="adj" fmla="val 5000"/>
+            </a:avLst>
+          </a:prstGeom>
+          <a:solidFill>
+            <a:srgbClr val="FFFFFF"/>
+          </a:solidFill>
+          <a:ln w="12700">
+            <a:solidFill>
+              <a:srgbClr val="DDE1E6"/>
+            </a:solidFill>
+          </a:ln>
+          <a:effectLst/>
+        </p:spPr>
+        <p:style>
+          <a:lnRef idx="1">
+            <a:schemeClr val="accent1"/>
+          </a:lnRef>
+          <a:fillRef idx="3">
+            <a:schemeClr val="accent1"/>
+          </a:fillRef>
+          <a:effectRef idx="2">
+            <a:schemeClr val="accent1"/>
+          </a:effectRef>
+          <a:fontRef idx="minor">
+            <a:schemeClr val="lt1"/>
+          </a:fontRef>
+        </p:style>
+        <p:txBody>
+          <a:bodyPr rtlCol="0" anchor="ctr"/>
+          <a:lstStyle/>
+          <a:p>
+            <a:pPr algn="ctr"/>
+          </a:p>
+        </p:txBody>
+      </p:sp>
+      <p:sp>
+        <p:nvSpPr>
+          <p:cNvPr id="21" name="Rectangle 20"/>
+          <p:cNvSpPr/>
+          <p:nvPr/>
+        </p:nvSpPr>
+        <p:spPr>
+          <a:xfrm>
+            <a:off x="457200" y="4233672"/>
+            <a:ext cx="73152" cy="2148840"/>
+          </a:xfrm>
+          <a:prstGeom prst="rect">
+            <a:avLst/>
+          </a:prstGeom>
+          <a:solidFill>
+            <a:srgbClr val="146EB4"/>
+          </a:solidFill>
+          <a:ln>
+            <a:noFill/>
+          </a:ln>
+          <a:effectLst/>
+        </p:spPr>
+        <p:style>
+          <a:lnRef idx="1">
+            <a:schemeClr val="accent1"/>
+          </a:lnRef>
+          <a:fillRef idx="3">
+            <a:schemeClr val="accent1"/>
+          </a:fillRef>
+          <a:effectRef idx="2">
+            <a:schemeClr val="accent1"/>
+          </a:effectRef>
+          <a:fontRef idx="minor">
+            <a:schemeClr val="lt1"/>
+          </a:fontRef>
+        </p:style>
+        <p:txBody>
+          <a:bodyPr rtlCol="0" anchor="ctr"/>
+          <a:lstStyle/>
+          <a:p>
+            <a:pPr algn="ctr"/>
+          </a:p>
+        </p:txBody>
+      </p:sp>
+      <p:sp>
+        <p:nvSpPr>
+          <p:cNvPr id="22" name="TextBox 21"/>
+          <p:cNvSpPr txBox="1"/>
+          <p:nvPr/>
+        </p:nvSpPr>
+        <p:spPr>
+          <a:xfrm>
+            <a:off x="685800" y="4379976"/>
+            <a:ext cx="3227832" cy="457200"/>
+          </a:xfrm>
+          <a:prstGeom prst="rect">
+            <a:avLst/>
+          </a:prstGeom>
+          <a:noFill/>
+        </p:spPr>
+        <p:txBody>
+          <a:bodyPr wrap="square" anchor="t" lIns="0" rIns="0" tIns="0" bIns="0">
+            <a:spAutoFit/>
+          </a:bodyPr>
+          <a:lstStyle/>
+          <a:p>
+            <a:pPr algn="l">
+              <a:lnSpc>
+                <a:spcPct val="100000"/>
+              </a:lnSpc>
+            </a:pPr>
+            <a:r>
+              <a:rPr sz="1350" b="1" i="0">
+                <a:solidFill>
+                  <a:srgbClr val="232F3E"/>
+                </a:solidFill>
+                <a:latin typeface="Calibri"/>
+              </a:rPr>
+              <a:t>Governed Tool Reuse</a:t>
+            </a:r>
+          </a:p>
+        </p:txBody>
+      </p:sp>
+      <p:sp>
+        <p:nvSpPr>
+          <p:cNvPr id="23" name="TextBox 22"/>
+          <p:cNvSpPr txBox="1"/>
+          <p:nvPr/>
+        </p:nvSpPr>
+        <p:spPr>
+          <a:xfrm>
+            <a:off x="685800" y="4855464"/>
+            <a:ext cx="3227832" cy="1371600"/>
+          </a:xfrm>
+          <a:prstGeom prst="rect">
+            <a:avLst/>
+          </a:prstGeom>
+          <a:noFill/>
+        </p:spPr>
+        <p:txBody>
+          <a:bodyPr wrap="square" anchor="t" lIns="0" rIns="0" tIns="0" bIns="0">
+            <a:spAutoFit/>
+          </a:bodyPr>
+          <a:lstStyle/>
+          <a:p>
+            <a:pPr algn="l">
+              <a:lnSpc>
+                <a:spcPct val="115000"/>
+              </a:lnSpc>
+            </a:pPr>
+            <a:r>
+              <a:rPr sz="1050" b="0" i="0">
+                <a:solidFill>
+                  <a:srgbClr val="5A636E"/>
+                </a:solidFill>
+                <a:latin typeface="Calibri"/>
+              </a:rPr>
+              <a:t>Tool logic now lives behind one AWS-managed access point, so the same governed data retrieval becomes directly reusable by future agents without re-implementing data access.</a:t>
+            </a:r>
+          </a:p>
+        </p:txBody>
+      </p:sp>
+      <p:sp>
+        <p:nvSpPr>
+          <p:cNvPr id="24" name="Rounded Rectangle 23"/>
+          <p:cNvSpPr/>
+          <p:nvPr/>
+        </p:nvSpPr>
+        <p:spPr>
+          <a:xfrm>
+            <a:off x="4233672" y="4233672"/>
+            <a:ext cx="3639312" cy="2148840"/>
+          </a:xfrm>
+          <a:prstGeom prst="roundRect">
+            <a:avLst>
+              <a:gd name="adj" fmla="val 5000"/>
+            </a:avLst>
+          </a:prstGeom>
+          <a:solidFill>
+            <a:srgbClr val="FFFFFF"/>
+          </a:solidFill>
+          <a:ln w="12700">
+            <a:solidFill>
+              <a:srgbClr val="DDE1E6"/>
+            </a:solidFill>
+          </a:ln>
+          <a:effectLst/>
+        </p:spPr>
+        <p:style>
+          <a:lnRef idx="1">
+            <a:schemeClr val="accent1"/>
+          </a:lnRef>
+          <a:fillRef idx="3">
+            <a:schemeClr val="accent1"/>
+          </a:fillRef>
+          <a:effectRef idx="2">
+            <a:schemeClr val="accent1"/>
+          </a:effectRef>
+          <a:fontRef idx="minor">
+            <a:schemeClr val="lt1"/>
+          </a:fontRef>
+        </p:style>
+        <p:txBody>
+          <a:bodyPr rtlCol="0" anchor="ctr"/>
+          <a:lstStyle/>
+          <a:p>
+            <a:pPr algn="ctr"/>
+          </a:p>
+        </p:txBody>
+      </p:sp>
+      <p:sp>
+        <p:nvSpPr>
+          <p:cNvPr id="25" name="Rectangle 24"/>
+          <p:cNvSpPr/>
+          <p:nvPr/>
+        </p:nvSpPr>
+        <p:spPr>
+          <a:xfrm>
+            <a:off x="4233672" y="4233672"/>
+            <a:ext cx="73152" cy="2148840"/>
+          </a:xfrm>
+          <a:prstGeom prst="rect">
+            <a:avLst/>
+          </a:prstGeom>
+          <a:solidFill>
+            <a:srgbClr val="146EB4"/>
+          </a:solidFill>
+          <a:ln>
+            <a:noFill/>
+          </a:ln>
+          <a:effectLst/>
+        </p:spPr>
+        <p:style>
+          <a:lnRef idx="1">
+            <a:schemeClr val="accent1"/>
+          </a:lnRef>
+          <a:fillRef idx="3">
+            <a:schemeClr val="accent1"/>
+          </a:fillRef>
+          <a:effectRef idx="2">
+            <a:schemeClr val="accent1"/>
+          </a:effectRef>
+          <a:fontRef idx="minor">
+            <a:schemeClr val="lt1"/>
+          </a:fontRef>
+        </p:style>
+        <p:txBody>
+          <a:bodyPr rtlCol="0" anchor="ctr"/>
+          <a:lstStyle/>
+          <a:p>
+            <a:pPr algn="ctr"/>
+          </a:p>
+        </p:txBody>
+      </p:sp>
+      <p:sp>
+        <p:nvSpPr>
+          <p:cNvPr id="26" name="TextBox 25"/>
+          <p:cNvSpPr txBox="1"/>
+          <p:nvPr/>
+        </p:nvSpPr>
+        <p:spPr>
+          <a:xfrm>
+            <a:off x="4462272" y="4379976"/>
+            <a:ext cx="3227832" cy="457200"/>
+          </a:xfrm>
+          <a:prstGeom prst="rect">
+            <a:avLst/>
+          </a:prstGeom>
+          <a:noFill/>
+        </p:spPr>
+        <p:txBody>
+          <a:bodyPr wrap="square" anchor="t" lIns="0" rIns="0" tIns="0" bIns="0">
+            <a:spAutoFit/>
+          </a:bodyPr>
+          <a:lstStyle/>
+          <a:p>
+            <a:pPr algn="l">
+              <a:lnSpc>
+                <a:spcPct val="100000"/>
+              </a:lnSpc>
+            </a:pPr>
+            <a:r>
+              <a:rPr sz="1350" b="1" i="0">
+                <a:solidFill>
+                  <a:srgbClr val="232F3E"/>
+                </a:solidFill>
+                <a:latin typeface="Calibri"/>
+              </a:rPr>
+              <a:t>Zero Added Compliance Risk</a:t>
+            </a:r>
+          </a:p>
+        </p:txBody>
+      </p:sp>
+      <p:sp>
+        <p:nvSpPr>
+          <p:cNvPr id="27" name="TextBox 26"/>
+          <p:cNvSpPr txBox="1"/>
+          <p:nvPr/>
+        </p:nvSpPr>
+        <p:spPr>
+          <a:xfrm>
+            <a:off x="4462272" y="4855464"/>
+            <a:ext cx="3227832" cy="1371600"/>
+          </a:xfrm>
+          <a:prstGeom prst="rect">
+            <a:avLst/>
+          </a:prstGeom>
+          <a:noFill/>
+        </p:spPr>
+        <p:txBody>
+          <a:bodyPr wrap="square" anchor="t" lIns="0" rIns="0" tIns="0" bIns="0">
+            <a:spAutoFit/>
+          </a:bodyPr>
+          <a:lstStyle/>
+          <a:p>
+            <a:pPr algn="l">
+              <a:lnSpc>
+                <a:spcPct val="115000"/>
+              </a:lnSpc>
+            </a:pPr>
+            <a:r>
+              <a:rPr sz="1050" b="0" i="0">
+                <a:solidFill>
+                  <a:srgbClr val="5A636E"/>
+                </a:solidFill>
+                <a:latin typeface="Calibri"/>
+              </a:rPr>
+              <a:t>Memory only supplies conversational context — every response is still independently synthesised, checked against the full rubric, and escalated exactly as before.</a:t>
+            </a:r>
+          </a:p>
+        </p:txBody>
+      </p:sp>
+      <p:sp>
+        <p:nvSpPr>
+          <p:cNvPr id="28" name="Rounded Rectangle 27"/>
+          <p:cNvSpPr/>
+          <p:nvPr/>
+        </p:nvSpPr>
+        <p:spPr>
+          <a:xfrm>
+            <a:off x="8010144" y="4233672"/>
+            <a:ext cx="3639312" cy="2148840"/>
+          </a:xfrm>
+          <a:prstGeom prst="roundRect">
+            <a:avLst>
+              <a:gd name="adj" fmla="val 5000"/>
+            </a:avLst>
+          </a:prstGeom>
+          <a:solidFill>
+            <a:srgbClr val="FFFFFF"/>
+          </a:solidFill>
+          <a:ln w="12700">
+            <a:solidFill>
+              <a:srgbClr val="DDE1E6"/>
+            </a:solidFill>
+          </a:ln>
+          <a:effectLst/>
+        </p:spPr>
+        <p:style>
+          <a:lnRef idx="1">
+            <a:schemeClr val="accent1"/>
+          </a:lnRef>
+          <a:fillRef idx="3">
+            <a:schemeClr val="accent1"/>
+          </a:fillRef>
+          <a:effectRef idx="2">
+            <a:schemeClr val="accent1"/>
+          </a:effectRef>
+          <a:fontRef idx="minor">
+            <a:schemeClr val="lt1"/>
+          </a:fontRef>
+        </p:style>
+        <p:txBody>
+          <a:bodyPr rtlCol="0" anchor="ctr"/>
+          <a:lstStyle/>
+          <a:p>
+            <a:pPr algn="ctr"/>
+          </a:p>
+        </p:txBody>
+      </p:sp>
+      <p:sp>
+        <p:nvSpPr>
+          <p:cNvPr id="29" name="Rectangle 28"/>
+          <p:cNvSpPr/>
+          <p:nvPr/>
+        </p:nvSpPr>
+        <p:spPr>
+          <a:xfrm>
+            <a:off x="8010144" y="4233672"/>
+            <a:ext cx="73152" cy="2148840"/>
+          </a:xfrm>
+          <a:prstGeom prst="rect">
+            <a:avLst/>
+          </a:prstGeom>
+          <a:solidFill>
+            <a:srgbClr val="146EB4"/>
+          </a:solidFill>
+          <a:ln>
+            <a:noFill/>
+          </a:ln>
+          <a:effectLst/>
+        </p:spPr>
+        <p:style>
+          <a:lnRef idx="1">
+            <a:schemeClr val="accent1"/>
+          </a:lnRef>
+          <a:fillRef idx="3">
+            <a:schemeClr val="accent1"/>
+          </a:fillRef>
+          <a:effectRef idx="2">
+            <a:schemeClr val="accent1"/>
+          </a:effectRef>
+          <a:fontRef idx="minor">
+            <a:schemeClr val="lt1"/>
+          </a:fontRef>
+        </p:style>
+        <p:txBody>
+          <a:bodyPr rtlCol="0" anchor="ctr"/>
+          <a:lstStyle/>
+          <a:p>
+            <a:pPr algn="ctr"/>
+          </a:p>
+        </p:txBody>
+      </p:sp>
+      <p:sp>
+        <p:nvSpPr>
+          <p:cNvPr id="30" name="TextBox 29"/>
+          <p:cNvSpPr txBox="1"/>
+          <p:nvPr/>
+        </p:nvSpPr>
+        <p:spPr>
+          <a:xfrm>
+            <a:off x="8238744" y="4379976"/>
+            <a:ext cx="3227832" cy="457200"/>
+          </a:xfrm>
+          <a:prstGeom prst="rect">
+            <a:avLst/>
+          </a:prstGeom>
+          <a:noFill/>
+        </p:spPr>
+        <p:txBody>
+          <a:bodyPr wrap="square" anchor="t" lIns="0" rIns="0" tIns="0" bIns="0">
+            <a:spAutoFit/>
+          </a:bodyPr>
+          <a:lstStyle/>
+          <a:p>
+            <a:pPr algn="l">
+              <a:lnSpc>
+                <a:spcPct val="100000"/>
+              </a:lnSpc>
+            </a:pPr>
+            <a:r>
+              <a:rPr sz="1350" b="1" i="0">
+                <a:solidFill>
+                  <a:srgbClr val="232F3E"/>
+                </a:solidFill>
+                <a:latin typeface="Calibri"/>
+              </a:rPr>
+              <a:t>Live-Verified, Not Just Deployed</a:t>
+            </a:r>
+          </a:p>
+        </p:txBody>
+      </p:sp>
+      <p:sp>
+        <p:nvSpPr>
+          <p:cNvPr id="31" name="TextBox 30"/>
+          <p:cNvSpPr txBox="1"/>
+          <p:nvPr/>
+        </p:nvSpPr>
+        <p:spPr>
+          <a:xfrm>
+            <a:off x="8238744" y="4855464"/>
+            <a:ext cx="3227832" cy="1371600"/>
+          </a:xfrm>
+          <a:prstGeom prst="rect">
+            <a:avLst/>
+          </a:prstGeom>
+          <a:noFill/>
+        </p:spPr>
+        <p:txBody>
+          <a:bodyPr wrap="square" anchor="t" lIns="0" rIns="0" tIns="0" bIns="0">
+            <a:spAutoFit/>
+          </a:bodyPr>
+          <a:lstStyle/>
+          <a:p>
+            <a:pPr algn="l">
+              <a:lnSpc>
+                <a:spcPct val="115000"/>
+              </a:lnSpc>
+            </a:pPr>
+            <a:r>
+              <a:rPr sz="1050" b="0" i="0">
+                <a:solidFill>
+                  <a:srgbClr val="5A636E"/>
+                </a:solidFill>
+                <a:latin typeface="Calibri"/>
+              </a:rPr>
+              <a:t>A real two-turn AWS test: an unnamed “that fund” follow-up was correctly resolved — confirmed in the answer and independently via the memory service.</a:t>
+            </a:r>
+          </a:p>
+        </p:txBody>
+      </p:sp>
+      <p:sp>
+        <p:nvSpPr>
+          <p:cNvPr id="32" name="TextBox 31"/>
+          <p:cNvSpPr txBox="1"/>
+          <p:nvPr/>
+        </p:nvSpPr>
+        <p:spPr>
+          <a:xfrm>
+            <a:off x="457200" y="6565392"/>
+            <a:ext cx="5486400" cy="256032"/>
+          </a:xfrm>
+          <a:prstGeom prst="rect">
+            <a:avLst/>
+          </a:prstGeom>
+          <a:noFill/>
+        </p:spPr>
+        <p:txBody>
+          <a:bodyPr wrap="square" anchor="t" lIns="0" rIns="0" tIns="0" bIns="0">
+            <a:spAutoFit/>
+          </a:bodyPr>
+          <a:lstStyle/>
+          <a:p>
+            <a:pPr algn="l">
+              <a:lnSpc>
+                <a:spcPct val="100000"/>
+              </a:lnSpc>
+            </a:pPr>
+            <a:r>
+              <a:rPr sz="900" b="0" i="0">
+                <a:solidFill>
+                  <a:srgbClr val="5A636E"/>
+                </a:solidFill>
+                <a:latin typeface="Calibri"/>
+              </a:rPr>
+              <a:t>AMC RFP &amp; Portfolio Insight Orchestrator</a:t>
+            </a:r>
+          </a:p>
+        </p:txBody>
+      </p:sp>
+      <p:sp>
+        <p:nvSpPr>
+          <p:cNvPr id="33" name="TextBox 32"/>
+          <p:cNvSpPr txBox="1"/>
+          <p:nvPr/>
+        </p:nvSpPr>
+        <p:spPr>
+          <a:xfrm>
+            <a:off x="9875520" y="6565392"/>
+            <a:ext cx="1874519" cy="256032"/>
+          </a:xfrm>
+          <a:prstGeom prst="rect">
+            <a:avLst/>
+          </a:prstGeom>
+          <a:noFill/>
+        </p:spPr>
+        <p:txBody>
+          <a:bodyPr wrap="square" anchor="t" lIns="0" rIns="0" tIns="0" bIns="0">
+            <a:spAutoFit/>
+          </a:bodyPr>
+          <a:lstStyle/>
+          <a:p>
+            <a:pPr algn="r">
+              <a:lnSpc>
+                <a:spcPct val="100000"/>
+              </a:lnSpc>
+            </a:pPr>
+            <a:r>
+              <a:rPr sz="900" b="0" i="0">
+                <a:solidFill>
+                  <a:srgbClr val="5A636E"/>
+                </a:solidFill>
+                <a:latin typeface="Calibri"/>
+              </a:rPr>
+              <a:t>13 / 18</a:t>
+            </a:r>
+          </a:p>
+        </p:txBody>
+      </p:sp>
+    </p:spTree>
+  </p:cSld>
+  <p:clrMapOvr>
+    <a:masterClrMapping/>
+  </p:clrMapOvr>
+</p:sld>
+</file>
+
+<file path=ppt/slides/slide14.xml><?xml version="1.0" encoding="utf-8"?>
 <p:sld xmlns:a="http://schemas.openxmlformats.org/drawingml/2006/main" xmlns:p="http://schemas.openxmlformats.org/presentationml/2006/main" xmlns:r="http://schemas.openxmlformats.org/officeDocument/2006/relationships">
   <p:cSld>
     <p:bg>
@@ -8394,7 +9755,7 @@
                 </a:solidFill>
                 <a:latin typeface="Calibri"/>
               </a:rPr>
-              <a:t>13</a:t>
+              <a:t>14</a:t>
             </a:r>
           </a:p>
         </p:txBody>
@@ -9490,7 +10851,7 @@
                 </a:solidFill>
                 <a:latin typeface="Calibri"/>
               </a:rPr>
-              <a:t>13 / 17</a:t>
+              <a:t>14 / 18</a:t>
             </a:r>
           </a:p>
         </p:txBody>
@@ -9503,7 +10864,7 @@
 </p:sld>
 </file>
 
-<file path=ppt/slides/slide14.xml><?xml version="1.0" encoding="utf-8"?>
+<file path=ppt/slides/slide15.xml><?xml version="1.0" encoding="utf-8"?>
 <p:sld xmlns:a="http://schemas.openxmlformats.org/drawingml/2006/main" xmlns:p="http://schemas.openxmlformats.org/presentationml/2006/main" xmlns:r="http://schemas.openxmlformats.org/officeDocument/2006/relationships">
   <p:cSld>
     <p:bg>
@@ -9721,7 +11082,7 @@
                 </a:solidFill>
                 <a:latin typeface="Calibri"/>
               </a:rPr>
-              <a:t>14</a:t>
+              <a:t>15</a:t>
             </a:r>
           </a:p>
         </p:txBody>
@@ -10985,7 +12346,7 @@
                 </a:solidFill>
                 <a:latin typeface="Calibri"/>
               </a:rPr>
-              <a:t>14 / 17</a:t>
+              <a:t>15 / 18</a:t>
             </a:r>
           </a:p>
         </p:txBody>
@@ -10998,7 +12359,7 @@
 </p:sld>
 </file>
 
-<file path=ppt/slides/slide15.xml><?xml version="1.0" encoding="utf-8"?>
+<file path=ppt/slides/slide16.xml><?xml version="1.0" encoding="utf-8"?>
 <p:sld xmlns:a="http://schemas.openxmlformats.org/drawingml/2006/main" xmlns:p="http://schemas.openxmlformats.org/presentationml/2006/main" xmlns:r="http://schemas.openxmlformats.org/officeDocument/2006/relationships">
   <p:cSld>
     <p:bg>
@@ -11216,7 +12577,7 @@
                 </a:solidFill>
                 <a:latin typeface="Calibri"/>
               </a:rPr>
-              <a:t>15</a:t>
+              <a:t>16</a:t>
             </a:r>
           </a:p>
         </p:txBody>
@@ -12589,7 +13950,7 @@
                 </a:solidFill>
                 <a:latin typeface="Calibri"/>
               </a:rPr>
-              <a:t>15 / 17</a:t>
+              <a:t>16 / 18</a:t>
             </a:r>
           </a:p>
         </p:txBody>
@@ -12602,7 +13963,7 @@
 </p:sld>
 </file>
 
-<file path=ppt/slides/slide16.xml><?xml version="1.0" encoding="utf-8"?>
+<file path=ppt/slides/slide17.xml><?xml version="1.0" encoding="utf-8"?>
 <p:sld xmlns:a="http://schemas.openxmlformats.org/drawingml/2006/main" xmlns:p="http://schemas.openxmlformats.org/presentationml/2006/main" xmlns:r="http://schemas.openxmlformats.org/officeDocument/2006/relationships">
   <p:cSld>
     <p:bg>
@@ -12820,7 +14181,7 @@
                 </a:solidFill>
                 <a:latin typeface="Calibri"/>
               </a:rPr>
-              <a:t>16</a:t>
+              <a:t>17</a:t>
             </a:r>
           </a:p>
         </p:txBody>
@@ -13690,7 +15051,7 @@
                 </a:solidFill>
                 <a:latin typeface="Calibri"/>
               </a:rPr>
-              <a:t>Staging / Production rollout</a:t>
+              <a:t>Phase 04 — Gateway &amp; Memory</a:t>
             </a:r>
           </a:p>
         </p:txBody>
@@ -13704,6 +15065,150 @@
         <p:spPr>
           <a:xfrm>
             <a:off x="9738360" y="3648456"/>
+            <a:ext cx="1828800" cy="347472"/>
+          </a:xfrm>
+          <a:prstGeom prst="roundRect">
+            <a:avLst>
+              <a:gd name="adj" fmla="val 50000"/>
+            </a:avLst>
+          </a:prstGeom>
+          <a:solidFill>
+            <a:srgbClr val="2E7D32"/>
+          </a:solidFill>
+          <a:ln>
+            <a:noFill/>
+          </a:ln>
+          <a:effectLst/>
+        </p:spPr>
+        <p:style>
+          <a:lnRef idx="1">
+            <a:schemeClr val="accent1"/>
+          </a:lnRef>
+          <a:fillRef idx="3">
+            <a:schemeClr val="accent1"/>
+          </a:fillRef>
+          <a:effectRef idx="2">
+            <a:schemeClr val="accent1"/>
+          </a:effectRef>
+          <a:fontRef idx="minor">
+            <a:schemeClr val="lt1"/>
+          </a:fontRef>
+        </p:style>
+        <p:txBody>
+          <a:bodyPr rtlCol="0" anchor="ctr" wrap="square" lIns="50800" rIns="50800" tIns="38100" bIns="38100"/>
+          <a:lstStyle/>
+          <a:p>
+            <a:pPr algn="ctr">
+              <a:lnSpc>
+                <a:spcPct val="100000"/>
+              </a:lnSpc>
+            </a:pPr>
+            <a:r>
+              <a:rPr sz="800" b="1">
+                <a:solidFill>
+                  <a:srgbClr val="FFFFFF"/>
+                </a:solidFill>
+                <a:latin typeface="Calibri"/>
+              </a:rPr>
+              <a:t>Live-verified on real AWS</a:t>
+            </a:r>
+          </a:p>
+        </p:txBody>
+      </p:sp>
+      <p:sp>
+        <p:nvSpPr>
+          <p:cNvPr id="24" name="Rounded Rectangle 23"/>
+          <p:cNvSpPr/>
+          <p:nvPr/>
+        </p:nvSpPr>
+        <p:spPr>
+          <a:xfrm>
+            <a:off x="6263640" y="4215384"/>
+            <a:ext cx="5440680" cy="566928"/>
+          </a:xfrm>
+          <a:prstGeom prst="roundRect">
+            <a:avLst>
+              <a:gd name="adj" fmla="val 12000"/>
+            </a:avLst>
+          </a:prstGeom>
+          <a:solidFill>
+            <a:srgbClr val="F2F3F5"/>
+          </a:solidFill>
+          <a:ln>
+            <a:noFill/>
+          </a:ln>
+          <a:effectLst/>
+        </p:spPr>
+        <p:style>
+          <a:lnRef idx="1">
+            <a:schemeClr val="accent1"/>
+          </a:lnRef>
+          <a:fillRef idx="3">
+            <a:schemeClr val="accent1"/>
+          </a:fillRef>
+          <a:effectRef idx="2">
+            <a:schemeClr val="accent1"/>
+          </a:effectRef>
+          <a:fontRef idx="minor">
+            <a:schemeClr val="lt1"/>
+          </a:fontRef>
+        </p:style>
+        <p:txBody>
+          <a:bodyPr rtlCol="0" anchor="ctr"/>
+          <a:lstStyle/>
+          <a:p>
+            <a:pPr algn="ctr"/>
+          </a:p>
+        </p:txBody>
+      </p:sp>
+      <p:sp>
+        <p:nvSpPr>
+          <p:cNvPr id="25" name="TextBox 24"/>
+          <p:cNvSpPr txBox="1"/>
+          <p:nvPr/>
+        </p:nvSpPr>
+        <p:spPr>
+          <a:xfrm>
+            <a:off x="6446520" y="4270248"/>
+            <a:ext cx="3200400" cy="457200"/>
+          </a:xfrm>
+          <a:prstGeom prst="rect">
+            <a:avLst/>
+          </a:prstGeom>
+          <a:noFill/>
+        </p:spPr>
+        <p:txBody>
+          <a:bodyPr wrap="square" anchor="ctr" lIns="0" rIns="0" tIns="0" bIns="0">
+            <a:spAutoFit/>
+          </a:bodyPr>
+          <a:lstStyle/>
+          <a:p>
+            <a:pPr algn="l">
+              <a:lnSpc>
+                <a:spcPct val="100000"/>
+              </a:lnSpc>
+            </a:pPr>
+            <a:r>
+              <a:rPr sz="1000" b="1" i="0">
+                <a:solidFill>
+                  <a:srgbClr val="22272B"/>
+                </a:solidFill>
+                <a:latin typeface="Calibri"/>
+              </a:rPr>
+              <a:t>Staging / Production rollout</a:t>
+            </a:r>
+          </a:p>
+        </p:txBody>
+      </p:sp>
+      <p:sp>
+        <p:nvSpPr>
+          <p:cNvPr id="26" name="Rounded Rectangle 25"/>
+          <p:cNvSpPr/>
+          <p:nvPr/>
+        </p:nvSpPr>
+        <p:spPr>
+          <a:xfrm>
+            <a:off x="9738360" y="4325112"/>
             <a:ext cx="1828800" cy="347472"/>
           </a:xfrm>
           <a:prstGeom prst="roundRect">
@@ -13756,150 +15261,6 @@
       </p:sp>
       <p:sp>
         <p:nvSpPr>
-          <p:cNvPr id="24" name="Rounded Rectangle 23"/>
-          <p:cNvSpPr/>
-          <p:nvPr/>
-        </p:nvSpPr>
-        <p:spPr>
-          <a:xfrm>
-            <a:off x="6263640" y="4215384"/>
-            <a:ext cx="5440680" cy="566928"/>
-          </a:xfrm>
-          <a:prstGeom prst="roundRect">
-            <a:avLst>
-              <a:gd name="adj" fmla="val 12000"/>
-            </a:avLst>
-          </a:prstGeom>
-          <a:solidFill>
-            <a:srgbClr val="F2F3F5"/>
-          </a:solidFill>
-          <a:ln>
-            <a:noFill/>
-          </a:ln>
-          <a:effectLst/>
-        </p:spPr>
-        <p:style>
-          <a:lnRef idx="1">
-            <a:schemeClr val="accent1"/>
-          </a:lnRef>
-          <a:fillRef idx="3">
-            <a:schemeClr val="accent1"/>
-          </a:fillRef>
-          <a:effectRef idx="2">
-            <a:schemeClr val="accent1"/>
-          </a:effectRef>
-          <a:fontRef idx="minor">
-            <a:schemeClr val="lt1"/>
-          </a:fontRef>
-        </p:style>
-        <p:txBody>
-          <a:bodyPr rtlCol="0" anchor="ctr"/>
-          <a:lstStyle/>
-          <a:p>
-            <a:pPr algn="ctr"/>
-          </a:p>
-        </p:txBody>
-      </p:sp>
-      <p:sp>
-        <p:nvSpPr>
-          <p:cNvPr id="25" name="TextBox 24"/>
-          <p:cNvSpPr txBox="1"/>
-          <p:nvPr/>
-        </p:nvSpPr>
-        <p:spPr>
-          <a:xfrm>
-            <a:off x="6446520" y="4270248"/>
-            <a:ext cx="3200400" cy="457200"/>
-          </a:xfrm>
-          <a:prstGeom prst="rect">
-            <a:avLst/>
-          </a:prstGeom>
-          <a:noFill/>
-        </p:spPr>
-        <p:txBody>
-          <a:bodyPr wrap="square" anchor="ctr" lIns="0" rIns="0" tIns="0" bIns="0">
-            <a:spAutoFit/>
-          </a:bodyPr>
-          <a:lstStyle/>
-          <a:p>
-            <a:pPr algn="l">
-              <a:lnSpc>
-                <a:spcPct val="100000"/>
-              </a:lnSpc>
-            </a:pPr>
-            <a:r>
-              <a:rPr sz="1000" b="1" i="0">
-                <a:solidFill>
-                  <a:srgbClr val="22272B"/>
-                </a:solidFill>
-                <a:latin typeface="Calibri"/>
-              </a:rPr>
-              <a:t>Gateway tools / AgentCore Memory</a:t>
-            </a:r>
-          </a:p>
-        </p:txBody>
-      </p:sp>
-      <p:sp>
-        <p:nvSpPr>
-          <p:cNvPr id="26" name="Rounded Rectangle 25"/>
-          <p:cNvSpPr/>
-          <p:nvPr/>
-        </p:nvSpPr>
-        <p:spPr>
-          <a:xfrm>
-            <a:off x="9738360" y="4325112"/>
-            <a:ext cx="1828800" cy="347472"/>
-          </a:xfrm>
-          <a:prstGeom prst="roundRect">
-            <a:avLst>
-              <a:gd name="adj" fmla="val 50000"/>
-            </a:avLst>
-          </a:prstGeom>
-          <a:solidFill>
-            <a:srgbClr val="5A636E"/>
-          </a:solidFill>
-          <a:ln>
-            <a:noFill/>
-          </a:ln>
-          <a:effectLst/>
-        </p:spPr>
-        <p:style>
-          <a:lnRef idx="1">
-            <a:schemeClr val="accent1"/>
-          </a:lnRef>
-          <a:fillRef idx="3">
-            <a:schemeClr val="accent1"/>
-          </a:fillRef>
-          <a:effectRef idx="2">
-            <a:schemeClr val="accent1"/>
-          </a:effectRef>
-          <a:fontRef idx="minor">
-            <a:schemeClr val="lt1"/>
-          </a:fontRef>
-        </p:style>
-        <p:txBody>
-          <a:bodyPr rtlCol="0" anchor="ctr" wrap="square" lIns="50800" rIns="50800" tIns="38100" bIns="38100"/>
-          <a:lstStyle/>
-          <a:p>
-            <a:pPr algn="ctr">
-              <a:lnSpc>
-                <a:spcPct val="100000"/>
-              </a:lnSpc>
-            </a:pPr>
-            <a:r>
-              <a:rPr sz="800" b="1">
-                <a:solidFill>
-                  <a:srgbClr val="FFFFFF"/>
-                </a:solidFill>
-                <a:latin typeface="Calibri"/>
-              </a:rPr>
-              <a:t>Provisioned, not yet wired in</a:t>
-            </a:r>
-          </a:p>
-        </p:txBody>
-      </p:sp>
-      <p:sp>
-        <p:nvSpPr>
           <p:cNvPr id="27" name="TextBox 26"/>
           <p:cNvSpPr txBox="1"/>
           <p:nvPr/>
@@ -14090,7 +15451,7 @@
                 </a:solidFill>
                 <a:latin typeface="Calibri"/>
               </a:rPr>
-              <a:t>16 / 17</a:t>
+              <a:t>17 / 18</a:t>
             </a:r>
           </a:p>
         </p:txBody>
@@ -14103,7 +15464,7 @@
 </p:sld>
 </file>
 
-<file path=ppt/slides/slide17.xml><?xml version="1.0" encoding="utf-8"?>
+<file path=ppt/slides/slide18.xml><?xml version="1.0" encoding="utf-8"?>
 <p:sld xmlns:a="http://schemas.openxmlformats.org/drawingml/2006/main" xmlns:p="http://schemas.openxmlformats.org/presentationml/2006/main" xmlns:r="http://schemas.openxmlformats.org/officeDocument/2006/relationships">
   <p:cSld>
     <p:bg>
@@ -14631,7 +15992,7 @@
                 </a:solidFill>
                 <a:latin typeface="Calibri"/>
               </a:rPr>
-              <a:t>6.  Wire in AgentCore Gateway tools &amp; AgentCore Memory</a:t>
+              <a:t>6.  Extend Gateway/Memory to Staging &amp; Production; add automated Memory test coverage</a:t>
             </a:r>
           </a:p>
         </p:txBody>
@@ -16069,7 +17430,7 @@
                 </a:solidFill>
                 <a:latin typeface="Calibri"/>
               </a:rPr>
-              <a:t>2 / 17</a:t>
+              <a:t>2 / 18</a:t>
             </a:r>
           </a:p>
         </p:txBody>
@@ -16701,7 +18062,7 @@
                 </a:solidFill>
                 <a:latin typeface="Calibri"/>
               </a:rPr>
-              <a:t>3 / 17</a:t>
+              <a:t>3 / 18</a:t>
             </a:r>
           </a:p>
         </p:txBody>
@@ -18222,7 +19583,7 @@
                 </a:solidFill>
                 <a:latin typeface="Calibri"/>
               </a:rPr>
-              <a:t>4 / 17</a:t>
+              <a:t>4 / 18</a:t>
             </a:r>
           </a:p>
         </p:txBody>
@@ -19590,7 +20951,7 @@
                 </a:solidFill>
                 <a:latin typeface="Calibri"/>
               </a:rPr>
-              <a:t>5 / 17</a:t>
+              <a:t>5 / 18</a:t>
             </a:r>
           </a:p>
         </p:txBody>
@@ -20650,7 +22011,7 @@
                 </a:solidFill>
                 <a:latin typeface="Calibri"/>
               </a:rPr>
-              <a:t>6 / 17</a:t>
+              <a:t>6 / 18</a:t>
             </a:r>
           </a:p>
         </p:txBody>
@@ -21938,7 +23299,7 @@
                 </a:solidFill>
                 <a:latin typeface="Calibri"/>
               </a:rPr>
-              <a:t>7 / 17</a:t>
+              <a:t>7 / 18</a:t>
             </a:r>
           </a:p>
         </p:txBody>
@@ -23201,7 +24562,7 @@
                 </a:solidFill>
                 <a:latin typeface="Calibri"/>
               </a:rPr>
-              <a:t>8 / 17</a:t>
+              <a:t>8 / 18</a:t>
             </a:r>
           </a:p>
         </p:txBody>
@@ -23385,7 +24746,7 @@
                 </a:solidFill>
                 <a:latin typeface="Calibri"/>
               </a:rPr>
-              <a:t>Three-Phase Delivery Journey — What Was Built</a:t>
+              <a:t>Delivery Journey — What Was Built</a:t>
             </a:r>
           </a:p>
         </p:txBody>
@@ -23463,7 +24824,7 @@
                 </a:solidFill>
                 <a:latin typeface="Calibri"/>
               </a:rPr>
-              <a:t>The same 5-agent system moved through three concrete build phases — free local development, a live AWS deployment, and a fully automated CI/CD pipeline.</a:t>
+              <a:t>The same 5-agent system moved through four concrete build phases — free local development, a live AWS deployment, a fully automated CI/CD pipeline, and governed tool access with conversational memory.</a:t>
             </a:r>
           </a:p>
         </p:txBody>
@@ -23477,7 +24838,7 @@
         <p:spPr>
           <a:xfrm>
             <a:off x="457200" y="1554480"/>
-            <a:ext cx="3606698" cy="600000"/>
+            <a:ext cx="2647874" cy="600000"/>
           </a:xfrm>
           <a:prstGeom prst="roundRect">
             <a:avLst>
@@ -23512,7 +24873,7 @@
           <a:p>
             <a:pPr algn="ctr"/>
             <a:r>
-              <a:rPr sz="1400" b="1">
+              <a:rPr sz="1100" b="1">
                 <a:solidFill>
                   <a:srgbClr val="FFFFFF"/>
                 </a:solidFill>
@@ -23528,7 +24889,7 @@
               </a:spcBef>
             </a:pPr>
             <a:r>
-              <a:rPr sz="1000" b="0">
+              <a:rPr sz="800" b="0">
                 <a:solidFill>
                   <a:srgbClr val="E6EEF6"/>
                 </a:solidFill>
@@ -23547,8 +24908,8 @@
         </p:nvSpPr>
         <p:spPr>
           <a:xfrm>
-            <a:off x="610549" y="2234480"/>
-            <a:ext cx="3300000" cy="302640"/>
+            <a:off x="457200" y="2234480"/>
+            <a:ext cx="2647874" cy="302640"/>
           </a:xfrm>
           <a:prstGeom prst="roundRect">
             <a:avLst>
@@ -23587,7 +24948,7 @@
               </a:lnSpc>
             </a:pPr>
             <a:r>
-              <a:rPr sz="800" b="1">
+              <a:rPr sz="700" b="1">
                 <a:solidFill>
                   <a:srgbClr val="FFFFFF"/>
                 </a:solidFill>
@@ -23607,7 +24968,7 @@
         <p:spPr>
           <a:xfrm>
             <a:off x="457200" y="2687120"/>
-            <a:ext cx="3606698" cy="3200000"/>
+            <a:ext cx="2647874" cy="3450000"/>
           </a:xfrm>
           <a:prstGeom prst="rect">
             <a:avLst/>
@@ -23629,13 +24990,13 @@
               </a:spcAft>
             </a:pPr>
             <a:r>
-              <a:rPr sz="1000" b="0">
+              <a:rPr sz="800" b="0">
                 <a:solidFill>
                   <a:srgbClr val="22272B"/>
                 </a:solidFill>
                 <a:latin typeface="Calibri"/>
               </a:rPr>
-              <a:t>▪  Built the 5-agent Strands graph — quant, qual, compliance, revisor, synthesizer</a:t>
+              <a:t>▪  5-agent Strands graph with a self-correcting, LLM-as-a-Judge compliance loop</a:t>
             </a:r>
           </a:p>
           <a:p>
@@ -23648,13 +25009,13 @@
               </a:spcAft>
             </a:pPr>
             <a:r>
-              <a:rPr sz="1000" b="0">
+              <a:rPr sz="800" b="0">
                 <a:solidFill>
                   <a:srgbClr val="22272B"/>
                 </a:solidFill>
                 <a:latin typeface="Calibri"/>
               </a:rPr>
-              <a:t>▪  Self-correcting compliance loop — LLM-as-a-Judge with structured, typed verdicts</a:t>
+              <a:t>▪  SQLite + ChromaDB data layer; Ollama (free, local) by default</a:t>
             </a:r>
           </a:p>
           <a:p>
@@ -23667,13 +25028,13 @@
               </a:spcAft>
             </a:pPr>
             <a:r>
-              <a:rPr sz="1000" b="0">
+              <a:rPr sz="800" b="0">
                 <a:solidFill>
                   <a:srgbClr val="22272B"/>
                 </a:solidFill>
                 <a:latin typeface="Calibri"/>
               </a:rPr>
-              <a:t>▪  SQLite + on-disk ChromaDB data layer; Ollama (free, local) by default</a:t>
+              <a:t>▪  FastAPI REST API + CLI, full unit + integration test suite</a:t>
             </a:r>
           </a:p>
           <a:p>
@@ -23686,26 +25047,7 @@
               </a:spcAft>
             </a:pPr>
             <a:r>
-              <a:rPr sz="1000" b="0">
-                <a:solidFill>
-                  <a:srgbClr val="22272B"/>
-                </a:solidFill>
-                <a:latin typeface="Calibri"/>
-              </a:rPr>
-              <a:t>▪  FastAPI REST API (/api/v1/rfp, /health) + CLI, full unit + integration test suite</a:t>
-            </a:r>
-          </a:p>
-          <a:p>
-            <a:pPr>
-              <a:lnSpc>
-                <a:spcPct val="105000"/>
-              </a:lnSpc>
-              <a:spcAft>
-                <a:spcPts val="500"/>
-              </a:spcAft>
-            </a:pPr>
-            <a:r>
-              <a:rPr sz="1000" b="0">
+              <a:rPr sz="800" b="0">
                 <a:solidFill>
                   <a:srgbClr val="22272B"/>
                 </a:solidFill>
@@ -23724,8 +25066,8 @@
         </p:nvSpPr>
         <p:spPr>
           <a:xfrm>
-            <a:off x="4292498" y="1554480"/>
-            <a:ext cx="3606698" cy="600000"/>
+            <a:off x="3333674" y="1554480"/>
+            <a:ext cx="2647874" cy="600000"/>
           </a:xfrm>
           <a:prstGeom prst="roundRect">
             <a:avLst>
@@ -23760,7 +25102,7 @@
           <a:p>
             <a:pPr algn="ctr"/>
             <a:r>
-              <a:rPr sz="1400" b="1">
+              <a:rPr sz="1100" b="1">
                 <a:solidFill>
                   <a:srgbClr val="FFFFFF"/>
                 </a:solidFill>
@@ -23776,7 +25118,7 @@
               </a:spcBef>
             </a:pPr>
             <a:r>
-              <a:rPr sz="1000" b="0">
+              <a:rPr sz="800" b="0">
                 <a:solidFill>
                   <a:srgbClr val="E6EEF6"/>
                 </a:solidFill>
@@ -23795,8 +25137,8 @@
         </p:nvSpPr>
         <p:spPr>
           <a:xfrm>
-            <a:off x="4445847" y="2234480"/>
-            <a:ext cx="3300000" cy="302640"/>
+            <a:off x="3333674" y="2234480"/>
+            <a:ext cx="2647874" cy="302640"/>
           </a:xfrm>
           <a:prstGeom prst="roundRect">
             <a:avLst>
@@ -23835,7 +25177,7 @@
               </a:lnSpc>
             </a:pPr>
             <a:r>
-              <a:rPr sz="800" b="1">
+              <a:rPr sz="700" b="1">
                 <a:solidFill>
                   <a:srgbClr val="FFFFFF"/>
                 </a:solidFill>
@@ -23854,8 +25196,8 @@
         </p:nvSpPr>
         <p:spPr>
           <a:xfrm>
-            <a:off x="4292498" y="2687120"/>
-            <a:ext cx="3606698" cy="3200000"/>
+            <a:off x="3333674" y="2687120"/>
+            <a:ext cx="2647874" cy="3450000"/>
           </a:xfrm>
           <a:prstGeom prst="rect">
             <a:avLst/>
@@ -23877,13 +25219,13 @@
               </a:spcAft>
             </a:pPr>
             <a:r>
-              <a:rPr sz="1000" b="0">
+              <a:rPr sz="800" b="0">
                 <a:solidFill>
                   <a:srgbClr val="22272B"/>
                 </a:solidFill>
                 <a:latin typeface="Calibri"/>
               </a:rPr>
-              <a:t>▪  Terraform IaC — AgentCore Runtime/Gateway/Memory, ECR, DynamoDB, OpenSearch/S3 Vectors, Bedrock KB</a:t>
+              <a:t>▪  Terraform IaC — AgentCore Runtime, ECR, DynamoDB, OpenSearch/S3 Vectors, Bedrock KB</a:t>
             </a:r>
           </a:p>
           <a:p>
@@ -23896,13 +25238,13 @@
               </a:spcAft>
             </a:pPr>
             <a:r>
-              <a:rPr sz="1000" b="0">
+              <a:rPr sz="800" b="0">
                 <a:solidFill>
                   <a:srgbClr val="22272B"/>
                 </a:solidFill>
                 <a:latin typeface="Calibri"/>
               </a:rPr>
-              <a:t>▪  AgentCore-compliant entrypoint + DynamoDB/Knowledge-Base data-layer swap, Dockerfile</a:t>
+              <a:t>▪  AgentCore entrypoint + DynamoDB/Knowledge-Base data-layer swap, Dockerfile</a:t>
             </a:r>
           </a:p>
           <a:p>
@@ -23915,7 +25257,7 @@
               </a:spcAft>
             </a:pPr>
             <a:r>
-              <a:rPr sz="1000" b="0">
+              <a:rPr sz="800" b="0">
                 <a:solidFill>
                   <a:srgbClr val="22272B"/>
                 </a:solidFill>
@@ -23934,32 +25276,13 @@
               </a:spcAft>
             </a:pPr>
             <a:r>
-              <a:rPr sz="1000" b="0">
+              <a:rPr sz="800" b="0">
                 <a:solidFill>
                   <a:srgbClr val="22272B"/>
                 </a:solidFill>
                 <a:latin typeface="Calibri"/>
               </a:rPr>
-              <a:t>▪  Auto-sync RAG ingestion pipeline (S3 → SQS → Lambda → Knowledge Base)</a:t>
-            </a:r>
-          </a:p>
-          <a:p>
-            <a:pPr>
-              <a:lnSpc>
-                <a:spcPct val="105000"/>
-              </a:lnSpc>
-              <a:spcAft>
-                <a:spcPts val="500"/>
-              </a:spcAft>
-            </a:pPr>
-            <a:r>
-              <a:rPr sz="1000" b="0">
-                <a:solidFill>
-                  <a:srgbClr val="22272B"/>
-                </a:solidFill>
-                <a:latin typeface="Calibri"/>
-              </a:rPr>
-              <a:t>▪  Streamlit UI extended with a SigV4-signed “Deployed Runtime” mode</a:t>
+              <a:t>▪  Auto-sync RAG ingestion (S3 → SQS → Lambda → Knowledge Base)</a:t>
             </a:r>
           </a:p>
         </p:txBody>
@@ -23972,8 +25295,8 @@
         </p:nvSpPr>
         <p:spPr>
           <a:xfrm>
-            <a:off x="8127796" y="1554480"/>
-            <a:ext cx="3606698" cy="600000"/>
+            <a:off x="6210148" y="1554480"/>
+            <a:ext cx="2647874" cy="600000"/>
           </a:xfrm>
           <a:prstGeom prst="roundRect">
             <a:avLst>
@@ -24008,7 +25331,7 @@
           <a:p>
             <a:pPr algn="ctr"/>
             <a:r>
-              <a:rPr sz="1400" b="1">
+              <a:rPr sz="1100" b="1">
                 <a:solidFill>
                   <a:srgbClr val="FFFFFF"/>
                 </a:solidFill>
@@ -24024,7 +25347,7 @@
               </a:spcBef>
             </a:pPr>
             <a:r>
-              <a:rPr sz="1000" b="0">
+              <a:rPr sz="800" b="0">
                 <a:solidFill>
                   <a:srgbClr val="E6EEF6"/>
                 </a:solidFill>
@@ -24043,8 +25366,8 @@
         </p:nvSpPr>
         <p:spPr>
           <a:xfrm>
-            <a:off x="8281145" y="2234480"/>
-            <a:ext cx="3300000" cy="302640"/>
+            <a:off x="6210148" y="2234480"/>
+            <a:ext cx="2647874" cy="302640"/>
           </a:xfrm>
           <a:prstGeom prst="roundRect">
             <a:avLst>
@@ -24083,7 +25406,7 @@
               </a:lnSpc>
             </a:pPr>
             <a:r>
-              <a:rPr sz="800" b="1">
+              <a:rPr sz="700" b="1">
                 <a:solidFill>
                   <a:srgbClr val="FFFFFF"/>
                 </a:solidFill>
@@ -24102,8 +25425,8 @@
         </p:nvSpPr>
         <p:spPr>
           <a:xfrm>
-            <a:off x="8127796" y="2687120"/>
-            <a:ext cx="3606698" cy="3200000"/>
+            <a:off x="6210148" y="2687120"/>
+            <a:ext cx="2647874" cy="3450000"/>
           </a:xfrm>
           <a:prstGeom prst="rect">
             <a:avLst/>
@@ -24125,13 +25448,13 @@
               </a:spcAft>
             </a:pPr>
             <a:r>
-              <a:rPr sz="1000" b="0">
+              <a:rPr sz="800" b="0">
                 <a:solidFill>
                   <a:srgbClr val="22272B"/>
                 </a:solidFill>
                 <a:latin typeface="Calibri"/>
               </a:rPr>
-              <a:t>▪  OIDC federated auth — no long-lived AWS keys, least-privilege per-environment roles</a:t>
+              <a:t>▪  OIDC federated auth — no long-lived AWS keys, least-privilege roles</a:t>
             </a:r>
           </a:p>
           <a:p>
@@ -24144,13 +25467,13 @@
               </a:spcAft>
             </a:pPr>
             <a:r>
-              <a:rPr sz="1000" b="0">
+              <a:rPr sz="800" b="0">
                 <a:solidFill>
                   <a:srgbClr val="22272B"/>
                 </a:solidFill>
                 <a:latin typeface="Calibri"/>
               </a:rPr>
-              <a:t>▪  pr-validate.yml — automatic lint/test/Docker-sanity/Terraform-plan on every PR</a:t>
+              <a:t>▪  pr-validate.yml (automatic) + deploy.yml (manual, build-once/promote)</a:t>
             </a:r>
           </a:p>
           <a:p>
@@ -24163,13 +25486,13 @@
               </a:spcAft>
             </a:pPr>
             <a:r>
-              <a:rPr sz="1000" b="0">
+              <a:rPr sz="800" b="0">
                 <a:solidFill>
                   <a:srgbClr val="22272B"/>
                 </a:solidFill>
                 <a:latin typeface="Calibri"/>
               </a:rPr>
-              <a:t>▪  deploy.yml — manual trigger, build-once, promote the same image across environments</a:t>
+              <a:t>▪  Proven via a real cold-start dev redeploy — 7 IAM gaps found &amp; fixed</a:t>
             </a:r>
           </a:p>
           <a:p>
@@ -24182,15 +25505,384 @@
               </a:spcAft>
             </a:pPr>
             <a:r>
-              <a:rPr sz="1000" b="0">
+              <a:rPr sz="800" b="0">
                 <a:solidFill>
                   <a:srgbClr val="22272B"/>
                 </a:solidFill>
                 <a:latin typeface="Calibri"/>
               </a:rPr>
-              <a:t>▪  Proven via a real cold-start dev redeploy — 7 rounds of real IAM gaps found &amp; fixed</a:t>
-            </a:r>
-          </a:p>
+              <a:t>▪  Staging/Production rollout designed, not yet executed</a:t>
+            </a:r>
+          </a:p>
+        </p:txBody>
+      </p:sp>
+      <p:sp>
+        <p:nvSpPr>
+          <p:cNvPr id="209" name="Flow Arrow 0"/>
+          <p:cNvSpPr txBox="1"/>
+          <p:nvPr/>
+        </p:nvSpPr>
+        <p:spPr>
+          <a:xfrm>
+            <a:off x="3105074" y="1554480"/>
+            <a:ext cx="228600" cy="600000"/>
+          </a:xfrm>
+          <a:prstGeom prst="rect">
+            <a:avLst/>
+          </a:prstGeom>
+          <a:noFill/>
+        </p:spPr>
+        <p:txBody>
+          <a:bodyPr wrap="square" anchor="ctr" lIns="0" rIns="0" tIns="0" bIns="0"/>
+          <a:lstStyle/>
+          <a:p>
+            <a:pPr algn="ctr"/>
+            <a:r>
+              <a:rPr sz="2000" b="1">
+                <a:solidFill>
+                  <a:srgbClr val="5A636E"/>
+                </a:solidFill>
+                <a:latin typeface="Calibri"/>
+              </a:rPr>
+              <a:t>→</a:t>
+            </a:r>
+          </a:p>
+        </p:txBody>
+      </p:sp>
+      <p:sp>
+        <p:nvSpPr>
+          <p:cNvPr id="210" name="Flow Arrow 1"/>
+          <p:cNvSpPr txBox="1"/>
+          <p:nvPr/>
+        </p:nvSpPr>
+        <p:spPr>
+          <a:xfrm>
+            <a:off x="5981548" y="1554480"/>
+            <a:ext cx="228600" cy="600000"/>
+          </a:xfrm>
+          <a:prstGeom prst="rect">
+            <a:avLst/>
+          </a:prstGeom>
+          <a:noFill/>
+        </p:spPr>
+        <p:txBody>
+          <a:bodyPr wrap="square" anchor="ctr" lIns="0" rIns="0" tIns="0" bIns="0"/>
+          <a:lstStyle/>
+          <a:p>
+            <a:pPr algn="ctr"/>
+            <a:r>
+              <a:rPr sz="2000" b="1">
+                <a:solidFill>
+                  <a:srgbClr val="5A636E"/>
+                </a:solidFill>
+                <a:latin typeface="Calibri"/>
+              </a:rPr>
+              <a:t>→</a:t>
+            </a:r>
+          </a:p>
+        </p:txBody>
+      </p:sp>
+      <p:sp>
+        <p:nvSpPr>
+          <p:cNvPr id="299" name="TextBox Caption"/>
+          <p:cNvSpPr txBox="1"/>
+          <p:nvPr/>
+        </p:nvSpPr>
+        <p:spPr>
+          <a:xfrm>
+            <a:off x="457200" y="6180000"/>
+            <a:ext cx="11277295" cy="256032"/>
+          </a:xfrm>
+          <a:prstGeom prst="rect">
+            <a:avLst/>
+          </a:prstGeom>
+          <a:noFill/>
+        </p:spPr>
+        <p:txBody>
+          <a:bodyPr wrap="square" anchor="t" lIns="0" rIns="0" tIns="0" bIns="0">
+            <a:spAutoFit/>
+          </a:bodyPr>
+          <a:lstStyle/>
+          <a:p>
+            <a:pPr algn="l">
+              <a:lnSpc>
+                <a:spcPct val="100000"/>
+              </a:lnSpc>
+            </a:pPr>
+            <a:r>
+              <a:rPr sz="900" b="0" i="1">
+                <a:solidFill>
+                  <a:srgbClr val="5A636E"/>
+                </a:solidFill>
+                <a:latin typeface="Calibri"/>
+              </a:rPr>
+              <a:t>Each phase builds directly on the previous one — the five core agents never change, only the deployment target, automation layer, and optional capabilities layered on top.</a:t>
+            </a:r>
+          </a:p>
+        </p:txBody>
+      </p:sp>
+      <p:sp>
+        <p:nvSpPr>
+          <p:cNvPr id="28" name="TextBox 27"/>
+          <p:cNvSpPr txBox="1"/>
+          <p:nvPr/>
+        </p:nvSpPr>
+        <p:spPr>
+          <a:xfrm>
+            <a:off x="457200" y="6565392"/>
+            <a:ext cx="5486400" cy="256032"/>
+          </a:xfrm>
+          <a:prstGeom prst="rect">
+            <a:avLst/>
+          </a:prstGeom>
+          <a:noFill/>
+        </p:spPr>
+        <p:txBody>
+          <a:bodyPr wrap="square" anchor="t" lIns="0" rIns="0" tIns="0" bIns="0">
+            <a:spAutoFit/>
+          </a:bodyPr>
+          <a:lstStyle/>
+          <a:p>
+            <a:pPr algn="l">
+              <a:lnSpc>
+                <a:spcPct val="100000"/>
+              </a:lnSpc>
+            </a:pPr>
+            <a:r>
+              <a:rPr sz="900" b="0" i="0">
+                <a:solidFill>
+                  <a:srgbClr val="5A636E"/>
+                </a:solidFill>
+                <a:latin typeface="Calibri"/>
+              </a:rPr>
+              <a:t>AMC RFP &amp; Portfolio Insight Orchestrator</a:t>
+            </a:r>
+          </a:p>
+        </p:txBody>
+      </p:sp>
+      <p:sp>
+        <p:nvSpPr>
+          <p:cNvPr id="29" name="TextBox 28"/>
+          <p:cNvSpPr txBox="1"/>
+          <p:nvPr/>
+        </p:nvSpPr>
+        <p:spPr>
+          <a:xfrm>
+            <a:off x="9875520" y="6565392"/>
+            <a:ext cx="1874519" cy="256032"/>
+          </a:xfrm>
+          <a:prstGeom prst="rect">
+            <a:avLst/>
+          </a:prstGeom>
+          <a:noFill/>
+        </p:spPr>
+        <p:txBody>
+          <a:bodyPr wrap="square" anchor="t" lIns="0" rIns="0" tIns="0" bIns="0">
+            <a:spAutoFit/>
+          </a:bodyPr>
+          <a:lstStyle/>
+          <a:p>
+            <a:pPr algn="r">
+              <a:lnSpc>
+                <a:spcPct val="100000"/>
+              </a:lnSpc>
+            </a:pPr>
+            <a:r>
+              <a:rPr sz="900" b="0" i="0">
+                <a:solidFill>
+                  <a:srgbClr val="5A636E"/>
+                </a:solidFill>
+                <a:latin typeface="Calibri"/>
+              </a:rPr>
+              <a:t>09 / 18</a:t>
+            </a:r>
+          </a:p>
+        </p:txBody>
+      </p:sp>
+      <p:sp>
+        <p:nvSpPr>
+          <p:cNvPr id="300" name="Flow Arrow 2"/>
+          <p:cNvSpPr txBox="1"/>
+          <p:nvPr/>
+        </p:nvSpPr>
+        <p:spPr>
+          <a:xfrm>
+            <a:off x="8858022" y="1554480"/>
+            <a:ext cx="228600" cy="600000"/>
+          </a:xfrm>
+          <a:prstGeom prst="rect">
+            <a:avLst/>
+          </a:prstGeom>
+          <a:noFill/>
+        </p:spPr>
+        <p:txBody>
+          <a:bodyPr wrap="square" anchor="ctr" lIns="0" rIns="0" tIns="0" bIns="0"/>
+          <a:lstStyle/>
+          <a:p>
+            <a:pPr algn="ctr"/>
+            <a:r>
+              <a:rPr sz="2000" b="1">
+                <a:solidFill>
+                  <a:srgbClr val="5A636E"/>
+                </a:solidFill>
+                <a:latin typeface="Calibri"/>
+              </a:rPr>
+              <a:t>→</a:t>
+            </a:r>
+          </a:p>
+        </p:txBody>
+      </p:sp>
+      <p:sp>
+        <p:nvSpPr>
+          <p:cNvPr id="301" name="Phase Header 3"/>
+          <p:cNvSpPr/>
+          <p:nvPr/>
+        </p:nvSpPr>
+        <p:spPr>
+          <a:xfrm>
+            <a:off x="9086622" y="1554480"/>
+            <a:ext cx="2647874" cy="600000"/>
+          </a:xfrm>
+          <a:prstGeom prst="roundRect">
+            <a:avLst>
+              <a:gd name="adj" fmla="val 8000"/>
+            </a:avLst>
+          </a:prstGeom>
+          <a:solidFill>
+            <a:srgbClr val="2E4157"/>
+          </a:solidFill>
+          <a:ln>
+            <a:noFill/>
+          </a:ln>
+          <a:effectLst/>
+        </p:spPr>
+        <p:style>
+          <a:lnRef idx="1">
+            <a:schemeClr val="accent1"/>
+          </a:lnRef>
+          <a:fillRef idx="3">
+            <a:schemeClr val="accent1"/>
+          </a:fillRef>
+          <a:effectRef idx="2">
+            <a:schemeClr val="accent1"/>
+          </a:effectRef>
+          <a:fontRef idx="minor">
+            <a:schemeClr val="lt1"/>
+          </a:fontRef>
+        </p:style>
+        <p:txBody>
+          <a:bodyPr rtlCol="0" anchor="ctr" wrap="square" lIns="76200" rIns="76200" tIns="50800" bIns="50800"/>
+          <a:lstStyle/>
+          <a:p>
+            <a:pPr algn="ctr"/>
+            <a:r>
+              <a:rPr sz="1100" b="1">
+                <a:solidFill>
+                  <a:srgbClr val="FFFFFF"/>
+                </a:solidFill>
+                <a:latin typeface="Calibri"/>
+              </a:rPr>
+              <a:t>PHASE 04</a:t>
+            </a:r>
+          </a:p>
+          <a:p>
+            <a:pPr algn="ctr">
+              <a:spcBef>
+                <a:spcPts val="200"/>
+              </a:spcBef>
+            </a:pPr>
+            <a:r>
+              <a:rPr sz="800" b="0">
+                <a:solidFill>
+                  <a:srgbClr val="E6EEF6"/>
+                </a:solidFill>
+                <a:latin typeface="Calibri"/>
+              </a:rPr>
+              <a:t>Gateway &amp; Memory (AgentCore)</a:t>
+            </a:r>
+          </a:p>
+        </p:txBody>
+      </p:sp>
+      <p:sp>
+        <p:nvSpPr>
+          <p:cNvPr id="302" name="Phase Pill 3"/>
+          <p:cNvSpPr/>
+          <p:nvPr/>
+        </p:nvSpPr>
+        <p:spPr>
+          <a:xfrm>
+            <a:off x="9086622" y="2234480"/>
+            <a:ext cx="2647874" cy="302640"/>
+          </a:xfrm>
+          <a:prstGeom prst="roundRect">
+            <a:avLst>
+              <a:gd name="adj" fmla="val 50000"/>
+            </a:avLst>
+          </a:prstGeom>
+          <a:solidFill>
+            <a:srgbClr val="2E7D32"/>
+          </a:solidFill>
+          <a:ln>
+            <a:noFill/>
+          </a:ln>
+          <a:effectLst/>
+        </p:spPr>
+        <p:style>
+          <a:lnRef idx="1">
+            <a:schemeClr val="accent1"/>
+          </a:lnRef>
+          <a:fillRef idx="3">
+            <a:schemeClr val="accent1"/>
+          </a:fillRef>
+          <a:effectRef idx="2">
+            <a:schemeClr val="accent1"/>
+          </a:effectRef>
+          <a:fontRef idx="minor">
+            <a:schemeClr val="lt1"/>
+          </a:fontRef>
+        </p:style>
+        <p:txBody>
+          <a:bodyPr rtlCol="0" anchor="ctr" wrap="square" lIns="50800" rIns="50800" tIns="38100" bIns="38100"/>
+          <a:lstStyle/>
+          <a:p>
+            <a:pPr algn="ctr">
+              <a:lnSpc>
+                <a:spcPct val="100000"/>
+              </a:lnSpc>
+            </a:pPr>
+            <a:r>
+              <a:rPr sz="700" b="1">
+                <a:solidFill>
+                  <a:srgbClr val="FFFFFF"/>
+                </a:solidFill>
+                <a:latin typeface="Calibri"/>
+              </a:rPr>
+              <a:t>Dev live-verified on real AWS</a:t>
+            </a:r>
+          </a:p>
+        </p:txBody>
+      </p:sp>
+      <p:sp>
+        <p:nvSpPr>
+          <p:cNvPr id="303" name="Phase Bullets 3"/>
+          <p:cNvSpPr txBox="1"/>
+          <p:nvPr/>
+        </p:nvSpPr>
+        <p:spPr>
+          <a:xfrm>
+            <a:off x="9086622" y="2687120"/>
+            <a:ext cx="2647874" cy="3450000"/>
+          </a:xfrm>
+          <a:prstGeom prst="rect">
+            <a:avLst/>
+          </a:prstGeom>
+          <a:noFill/>
+        </p:spPr>
+        <p:txBody>
+          <a:bodyPr wrap="square">
+            <a:spAutoFit/>
+          </a:bodyPr>
+          <a:lstStyle/>
           <a:p>
             <a:pPr>
               <a:lnSpc>
@@ -24201,196 +25893,70 @@
               </a:spcAft>
             </a:pPr>
             <a:r>
-              <a:rPr sz="1000" b="0">
+              <a:rPr sz="800" b="0">
                 <a:solidFill>
                   <a:srgbClr val="22272B"/>
                 </a:solidFill>
                 <a:latin typeface="Calibri"/>
               </a:rPr>
-              <a:t>▪  Staging/Production rollout designed, not yet executed</a:t>
-            </a:r>
-          </a:p>
-        </p:txBody>
-      </p:sp>
-      <p:sp>
-        <p:nvSpPr>
-          <p:cNvPr id="209" name="Flow Arrow 0"/>
-          <p:cNvSpPr txBox="1"/>
-          <p:nvPr/>
-        </p:nvSpPr>
-        <p:spPr>
-          <a:xfrm>
-            <a:off x="4063898" y="1554480"/>
-            <a:ext cx="228600" cy="600000"/>
-          </a:xfrm>
-          <a:prstGeom prst="rect">
-            <a:avLst/>
-          </a:prstGeom>
-          <a:noFill/>
-        </p:spPr>
-        <p:txBody>
-          <a:bodyPr wrap="square" anchor="ctr" lIns="0" rIns="0" tIns="0" bIns="0"/>
-          <a:lstStyle/>
-          <a:p>
-            <a:pPr algn="ctr"/>
-            <a:r>
-              <a:rPr sz="2000" b="1">
-                <a:solidFill>
-                  <a:srgbClr val="5A636E"/>
-                </a:solidFill>
-                <a:latin typeface="Calibri"/>
-              </a:rPr>
-              <a:t>→</a:t>
-            </a:r>
-          </a:p>
-        </p:txBody>
-      </p:sp>
-      <p:sp>
-        <p:nvSpPr>
-          <p:cNvPr id="210" name="Flow Arrow 1"/>
-          <p:cNvSpPr txBox="1"/>
-          <p:nvPr/>
-        </p:nvSpPr>
-        <p:spPr>
-          <a:xfrm>
-            <a:off x="7899196" y="1554480"/>
-            <a:ext cx="228600" cy="600000"/>
-          </a:xfrm>
-          <a:prstGeom prst="rect">
-            <a:avLst/>
-          </a:prstGeom>
-          <a:noFill/>
-        </p:spPr>
-        <p:txBody>
-          <a:bodyPr wrap="square" anchor="ctr" lIns="0" rIns="0" tIns="0" bIns="0"/>
-          <a:lstStyle/>
-          <a:p>
-            <a:pPr algn="ctr"/>
-            <a:r>
-              <a:rPr sz="2000" b="1">
-                <a:solidFill>
-                  <a:srgbClr val="5A636E"/>
-                </a:solidFill>
-                <a:latin typeface="Calibri"/>
-              </a:rPr>
-              <a:t>→</a:t>
-            </a:r>
-          </a:p>
-        </p:txBody>
-      </p:sp>
-      <p:sp>
-        <p:nvSpPr>
-          <p:cNvPr id="299" name="TextBox Caption"/>
-          <p:cNvSpPr txBox="1"/>
-          <p:nvPr/>
-        </p:nvSpPr>
-        <p:spPr>
-          <a:xfrm>
-            <a:off x="457200" y="6180000"/>
-            <a:ext cx="11277295" cy="256032"/>
-          </a:xfrm>
-          <a:prstGeom prst="rect">
-            <a:avLst/>
-          </a:prstGeom>
-          <a:noFill/>
-        </p:spPr>
-        <p:txBody>
-          <a:bodyPr wrap="square" anchor="t" lIns="0" rIns="0" tIns="0" bIns="0">
-            <a:spAutoFit/>
-          </a:bodyPr>
-          <a:lstStyle/>
-          <a:p>
-            <a:pPr algn="l">
-              <a:lnSpc>
-                <a:spcPct val="100000"/>
-              </a:lnSpc>
-            </a:pPr>
-            <a:r>
-              <a:rPr sz="900" b="0" i="1">
-                <a:solidFill>
-                  <a:srgbClr val="5A636E"/>
-                </a:solidFill>
-                <a:latin typeface="Calibri"/>
-              </a:rPr>
-              <a:t>Each phase builds directly on the previous one — the agent and tool code never changes, only the deployment target and automation layer.</a:t>
-            </a:r>
-          </a:p>
-        </p:txBody>
-      </p:sp>
-      <p:sp>
-        <p:nvSpPr>
-          <p:cNvPr id="28" name="TextBox 27"/>
-          <p:cNvSpPr txBox="1"/>
-          <p:nvPr/>
-        </p:nvSpPr>
-        <p:spPr>
-          <a:xfrm>
-            <a:off x="457200" y="6565392"/>
-            <a:ext cx="5486400" cy="256032"/>
-          </a:xfrm>
-          <a:prstGeom prst="rect">
-            <a:avLst/>
-          </a:prstGeom>
-          <a:noFill/>
-        </p:spPr>
-        <p:txBody>
-          <a:bodyPr wrap="square" anchor="t" lIns="0" rIns="0" tIns="0" bIns="0">
-            <a:spAutoFit/>
-          </a:bodyPr>
-          <a:lstStyle/>
-          <a:p>
-            <a:pPr algn="l">
-              <a:lnSpc>
-                <a:spcPct val="100000"/>
-              </a:lnSpc>
-            </a:pPr>
-            <a:r>
-              <a:rPr sz="900" b="0" i="0">
-                <a:solidFill>
-                  <a:srgbClr val="5A636E"/>
-                </a:solidFill>
-                <a:latin typeface="Calibri"/>
-              </a:rPr>
-              <a:t>AMC RFP &amp; Portfolio Insight Orchestrator</a:t>
-            </a:r>
-          </a:p>
-        </p:txBody>
-      </p:sp>
-      <p:sp>
-        <p:nvSpPr>
-          <p:cNvPr id="29" name="TextBox 28"/>
-          <p:cNvSpPr txBox="1"/>
-          <p:nvPr/>
-        </p:nvSpPr>
-        <p:spPr>
-          <a:xfrm>
-            <a:off x="9875520" y="6565392"/>
-            <a:ext cx="1874519" cy="256032"/>
-          </a:xfrm>
-          <a:prstGeom prst="rect">
-            <a:avLst/>
-          </a:prstGeom>
-          <a:noFill/>
-        </p:spPr>
-        <p:txBody>
-          <a:bodyPr wrap="square" anchor="t" lIns="0" rIns="0" tIns="0" bIns="0">
-            <a:spAutoFit/>
-          </a:bodyPr>
-          <a:lstStyle/>
-          <a:p>
-            <a:pPr algn="r">
-              <a:lnSpc>
-                <a:spcPct val="100000"/>
-              </a:lnSpc>
-            </a:pPr>
-            <a:r>
-              <a:rPr sz="900" b="0" i="0">
-                <a:solidFill>
-                  <a:srgbClr val="5A636E"/>
-                </a:solidFill>
-                <a:latin typeface="Calibri"/>
-              </a:rPr>
-              <a:t>09 / 17</a:t>
+              <a:t>▪  Real Lambda logic behind the Gateway; SigV4-signed tool routing</a:t>
+            </a:r>
+          </a:p>
+          <a:p>
+            <a:pPr>
+              <a:lnSpc>
+                <a:spcPct val="105000"/>
+              </a:lnSpc>
+              <a:spcAft>
+                <a:spcPts val="500"/>
+              </a:spcAft>
+            </a:pPr>
+            <a:r>
+              <a:rPr sz="800" b="0">
+                <a:solidFill>
+                  <a:srgbClr val="22272B"/>
+                </a:solidFill>
+                <a:latin typeface="Calibri"/>
+              </a:rPr>
+              <a:t>▪  Real cross-turn AgentCore Memory read/write around the graph</a:t>
+            </a:r>
+          </a:p>
+          <a:p>
+            <a:pPr>
+              <a:lnSpc>
+                <a:spcPct val="105000"/>
+              </a:lnSpc>
+              <a:spcAft>
+                <a:spcPts val="500"/>
+              </a:spcAft>
+            </a:pPr>
+            <a:r>
+              <a:rPr sz="800" b="0">
+                <a:solidFill>
+                  <a:srgbClr val="22272B"/>
+                </a:solidFill>
+                <a:latin typeface="Calibri"/>
+              </a:rPr>
+              <a:t>▪  Both opt-in by configuration — zero change to agent behaviour</a:t>
+            </a:r>
+          </a:p>
+          <a:p>
+            <a:pPr>
+              <a:lnSpc>
+                <a:spcPct val="105000"/>
+              </a:lnSpc>
+              <a:spcAft>
+                <a:spcPts val="500"/>
+              </a:spcAft>
+            </a:pPr>
+            <a:r>
+              <a:rPr sz="800" b="0">
+                <a:solidFill>
+                  <a:srgbClr val="22272B"/>
+                </a:solidFill>
+                <a:latin typeface="Calibri"/>
+              </a:rPr>
+              <a:t>▪  Live-verified: real two-turn AWS test, confirmed via CloudWatch logs</a:t>
             </a:r>
           </a:p>
         </p:txBody>

</xml_diff>

<commit_message>
feat: implement AgentCore Policy (Cedar authorization), currently blocked by a real AWS issue
Adds a Cedar-based authorization layer (WS10) on top of the AgentCore
Gateway from WS8: a new agentcore-policy Terraform module (policy engine +
per-tool allow-list/input-validation policies), gateway/IAM wiring across
all three environments, and a GatewayPolicyDenialHookProvider so a denial
is reported honestly instead of fabricated or leaked to the client.

Terraform applies cleanly and was live-verified end to end, but attaching
the policy engine to the Gateway - even in log-only mode - makes every
tool call fail with a generic AWS-side InternalServerException, reproduced
consistently and confirmed not caller-identity-related. Policy stays
switched off (enable_policy=false) in dev pending resolution.

Also updates Execution-05.md, architecture.md, ci_cd_runbook.md, the
project report docx, and the Phase 04 deck to document the capability and
its known blocker.
</commit_message>
<xml_diff>
--- a/docs/AMC_RFP_Orchestrator_Project_Phase01_Phase02_Phase03_Phase04.pptx
+++ b/docs/AMC_RFP_Orchestrator_Project_Phase01_Phase02_Phase03_Phase04.pptx
@@ -8348,7 +8348,7 @@
                 </a:solidFill>
                 <a:latin typeface="Calibri"/>
               </a:rPr>
-              <a:t>Gateway-Routed Tools &amp; AgentCore Memory</a:t>
+              <a:t>Gateway-Routed Tools, AgentCore Memory &amp; Policy</a:t>
             </a:r>
           </a:p>
         </p:txBody>
@@ -8426,7 +8426,7 @@
                 </a:solidFill>
                 <a:latin typeface="Calibri"/>
               </a:rPr>
-              <a:t>Two AWS capabilities provisioned since Phase 02 — governed tool access and cross-turn conversation memory — are now real, working, and live-verified end-to-end against real AWS.</a:t>
+              <a:t>Three AWS capabilities provisioned since Phase 02 — governed tool access, cross-turn conversation memory, and Cedar-based tool authorization. Gateway and Memory are real, working, and live-verified end-to-end against real AWS; Policy is built and applies cleanly but is currently blocked by a real AWS-side issue.</a:t>
             </a:r>
           </a:p>
         </p:txBody>
@@ -9067,7 +9067,7 @@
                 </a:solidFill>
                 <a:latin typeface="Calibri"/>
               </a:rPr>
-              <a:t>Governed Tool Reuse</a:t>
+              <a:t>AgentCore Policy</a:t>
             </a:r>
           </a:p>
         </p:txBody>
@@ -9106,7 +9106,7 @@
                 </a:solidFill>
                 <a:latin typeface="Calibri"/>
               </a:rPr>
-              <a:t>Tool logic now lives behind one AWS-managed access point, so the same governed data retrieval becomes directly reusable by future agents without re-implementing data access.</a:t>
+              <a:t>A Cedar-based authorization layer now attaches to the Gateway, allow-listing both tools by name and validating their inputs — built and applying cleanly to real AWS, but blocked by a real platform-side issue that fails every tool call once attached; switched off until resolved.</a:t>
             </a:r>
           </a:p>
         </p:txBody>
@@ -15051,7 +15051,7 @@
                 </a:solidFill>
                 <a:latin typeface="Calibri"/>
               </a:rPr>
-              <a:t>Phase 04 — Gateway &amp; Memory</a:t>
+              <a:t>Phase 04 — Gateway, Memory &amp; Policy</a:t>
             </a:r>
           </a:p>
         </p:txBody>
@@ -15073,7 +15073,7 @@
             </a:avLst>
           </a:prstGeom>
           <a:solidFill>
-            <a:srgbClr val="2E7D32"/>
+            <a:srgbClr val="E87B00"/>
           </a:solidFill>
           <a:ln>
             <a:noFill/>
@@ -15110,7 +15110,7 @@
                 </a:solidFill>
                 <a:latin typeface="Calibri"/>
               </a:rPr>
-              <a:t>Live-verified on real AWS</a:t>
+              <a:t>Gateway/Memory live; Policy blocked</a:t>
             </a:r>
           </a:p>
         </p:txBody>
@@ -15992,7 +15992,7 @@
                 </a:solidFill>
                 <a:latin typeface="Calibri"/>
               </a:rPr>
-              <a:t>6.  Extend Gateway/Memory to Staging &amp; Production; add automated Memory test coverage</a:t>
+              <a:t>6.  Extend Gateway/Memory to Staging &amp; Production; resolve the AgentCore Policy platform blocker</a:t>
             </a:r>
           </a:p>
         </p:txBody>
@@ -24824,7 +24824,7 @@
                 </a:solidFill>
                 <a:latin typeface="Calibri"/>
               </a:rPr>
-              <a:t>The same 5-agent system moved through four concrete build phases — free local development, a live AWS deployment, a fully automated CI/CD pipeline, and governed tool access with conversational memory.</a:t>
+              <a:t>The same 5-agent system moved through four concrete build phases — free local development, a live AWS deployment, a fully automated CI/CD pipeline, and governed tool access, conversational memory, and Cedar-based authorization controls.</a:t>
             </a:r>
           </a:p>
         </p:txBody>
@@ -25798,7 +25798,7 @@
                 </a:solidFill>
                 <a:latin typeface="Calibri"/>
               </a:rPr>
-              <a:t>Gateway &amp; Memory (AgentCore)</a:t>
+              <a:t>Gateway, Memory &amp; Policy (AgentCore)</a:t>
             </a:r>
           </a:p>
         </p:txBody>
@@ -25820,7 +25820,7 @@
             </a:avLst>
           </a:prstGeom>
           <a:solidFill>
-            <a:srgbClr val="2E7D32"/>
+            <a:srgbClr val="E87B00"/>
           </a:solidFill>
           <a:ln>
             <a:noFill/>
@@ -25857,7 +25857,7 @@
                 </a:solidFill>
                 <a:latin typeface="Calibri"/>
               </a:rPr>
-              <a:t>Dev live-verified on real AWS</a:t>
+              <a:t>Gateway/Memory live; Policy blocked</a:t>
             </a:r>
           </a:p>
         </p:txBody>
@@ -25937,7 +25937,7 @@
                 </a:solidFill>
                 <a:latin typeface="Calibri"/>
               </a:rPr>
-              <a:t>▪  Both opt-in by configuration — zero change to agent behaviour</a:t>
+              <a:t>▪  AgentCore Policy (Cedar authorization) built, applies cleanly — blocked by a real AWS-side issue</a:t>
             </a:r>
           </a:p>
           <a:p>

</xml_diff>